<commit_message>
:pencil: edit lect 1
</commit_message>
<xml_diff>
--- a/lessons/lesson01_biological_question/theory/slides/Lecture1 - From Biological Question to ML Problem.pptx
+++ b/lessons/lesson01_biological_question/theory/slides/Lecture1 - From Biological Question to ML Problem.pptx
@@ -17338,7 +17338,7 @@
                 <a:ea typeface="Calibri" pitchFamily="34" charset="-122"/>
                 <a:cs typeface="Calibri" pitchFamily="34" charset="-120"/>
               </a:rPr>
-              <a:t>Research-grade ML</a:t>
+              <a:t>A good ML model</a:t>
             </a:r>
             <a:endParaRPr lang="en-US" sz="1400" dirty="0"/>
           </a:p>
@@ -22286,7 +22286,7 @@
                 <a:ea typeface="Cambria" pitchFamily="34" charset="-122"/>
                 <a:cs typeface="Cambria" pitchFamily="34" charset="-120"/>
               </a:rPr>
-              <a:t>Who needs more therapy — and who is harmed by it?</a:t>
+              <a:t>Who needs more therapy and who is harmed by it?</a:t>
             </a:r>
             <a:endParaRPr lang="en-US" sz="3000" dirty="0"/>
           </a:p>
@@ -22407,7 +22407,7 @@
                 <a:ea typeface="Calibri" pitchFamily="34" charset="-122"/>
                 <a:cs typeface="Calibri" pitchFamily="34" charset="-120"/>
               </a:rPr>
-              <a:t>HR+/HER2− early breast cancer: the most common subtype (~70% of cases).</a:t>
+              <a:t>HR+/HER2- early breast cancer: the most common subtype (~70% of cases).</a:t>
             </a:r>
             <a:endParaRPr lang="en-US" sz="1600" dirty="0"/>
           </a:p>
@@ -22428,7 +22428,7 @@
                 <a:ea typeface="Calibri" pitchFamily="34" charset="-122"/>
                 <a:cs typeface="Calibri" pitchFamily="34" charset="-120"/>
               </a:rPr>
-              <a:t>Generally good prognosis, but heterogeneous — some tumours need chemotherapy, many do not.</a:t>
+              <a:t>Generally good prognosis, but heterogeneous. Some tumours need chemotherapy, many do not.</a:t>
             </a:r>
             <a:endParaRPr lang="en-US" sz="1600" dirty="0"/>
           </a:p>
@@ -22449,7 +22449,7 @@
                 <a:ea typeface="Calibri" pitchFamily="34" charset="-122"/>
                 <a:cs typeface="Calibri" pitchFamily="34" charset="-120"/>
               </a:rPr>
-              <a:t>Central tension: overtreatment (toxicity, cost, harm to patients who would have done well) vs undertreatment (missed recurrences).</a:t>
+              <a:t>Central tension: overtreatment (toxicity such as heart damage, infertility, secondary AML) vs undertreatment (metastatic recurrences).</a:t>
             </a:r>
             <a:endParaRPr lang="en-US" sz="1600" dirty="0"/>
           </a:p>

</xml_diff>

<commit_message>
:pencil: Final edit lect 1
</commit_message>
<xml_diff>
--- a/lessons/lesson01_biological_question/theory/slides/Lecture1 - From Biological Question to ML Problem.pptx
+++ b/lessons/lesson01_biological_question/theory/slides/Lecture1 - From Biological Question to ML Problem.pptx
@@ -5,7 +5,7 @@
     <p:sldMasterId id="2147483648" r:id="rId1"/>
   </p:sldMasterIdLst>
   <p:notesMasterIdLst>
-    <p:notesMasterId r:id="rId27"/>
+    <p:notesMasterId r:id="rId26"/>
   </p:notesMasterIdLst>
   <p:sldIdLst>
     <p:sldId id="256" r:id="rId2"/>
@@ -25,14 +25,13 @@
     <p:sldId id="270" r:id="rId16"/>
     <p:sldId id="271" r:id="rId17"/>
     <p:sldId id="272" r:id="rId18"/>
-    <p:sldId id="273" r:id="rId19"/>
-    <p:sldId id="274" r:id="rId20"/>
-    <p:sldId id="275" r:id="rId21"/>
-    <p:sldId id="276" r:id="rId22"/>
-    <p:sldId id="277" r:id="rId23"/>
-    <p:sldId id="278" r:id="rId24"/>
-    <p:sldId id="279" r:id="rId25"/>
-    <p:sldId id="280" r:id="rId26"/>
+    <p:sldId id="274" r:id="rId19"/>
+    <p:sldId id="275" r:id="rId20"/>
+    <p:sldId id="276" r:id="rId21"/>
+    <p:sldId id="277" r:id="rId22"/>
+    <p:sldId id="278" r:id="rId23"/>
+    <p:sldId id="279" r:id="rId24"/>
+    <p:sldId id="280" r:id="rId25"/>
   </p:sldIdLst>
   <p:sldSz cx="12192000" cy="6858000"/>
   <p:notesSz cx="6858000" cy="12192000"/>
@@ -1903,7 +1902,7 @@
               </a:defRPr>
             </a:pPr>
             <a:r>
-              <a:rPr sz="1200" b="0" i="0" u="none" strike="noStrike">
+              <a:rPr lang="en-GB" sz="1200" b="0" i="0" u="none" strike="noStrike">
                 <a:solidFill>
                   <a:srgbClr val="12262B"/>
                 </a:solidFill>
@@ -3239,7 +3238,7 @@
           <a:p>
             <a:r>
               <a:rPr lang="en-US" dirty="0"/>
-              <a:t>4 min. Chemosensitivity signatures published in top journals, headed to clinical trials, later retracted amid irreproducibility and data errors. Baggerly &amp; Coombes could not reproduce; trials suspended. Lesson is not 'bad scientists' — the pipeline was undocumented and these failure modes were uncontrolled. VERIFY exact dates before presenting.</a:t>
+              <a:t>4 min. Optimistic bias from leakage/tuning on test; tiny underpowered cohorts in p&gt;&gt;n; batch confounding read as biology; overfitting to one dataset; selective reporting. Pattern: spectacular discovery, silent validation failure.</a:t>
             </a:r>
           </a:p>
         </p:txBody>
@@ -3326,7 +3325,7 @@
           <a:p>
             <a:r>
               <a:rPr lang="en-US" dirty="0"/>
-              <a:t>4 min. Optimistic bias from leakage/tuning on test; tiny underpowered cohorts in p&gt;&gt;n; batch confounding read as biology; overfitting to one dataset; selective reporting. Pattern: spectacular discovery, silent validation failure.</a:t>
+              <a:t>3 min. The clinically adopted multi-gene recurrence assays share: pre-specified locked signatures, independent multi-cohort validation, demonstrated clinical utility. Rigour in framing and validation, not algorithmic novelty, made them trustworthy.</a:t>
             </a:r>
           </a:p>
         </p:txBody>
@@ -3500,7 +3499,7 @@
           <a:p>
             <a:r>
               <a:rPr lang="en-US" dirty="0"/>
-              <a:t>3 min. The clinically adopted multi-gene recurrence assays share: pre-specified locked signatures, independent multi-cohort validation, demonstrated clinical utility. Rigour in framing and validation, not algorithmic novelty, made them trustworthy.</a:t>
+              <a:t>4 min. Order of operations is a scientific commitment: lock question &amp; label; split first; everything data-dependent happens inside training only; touch the test set once at the end. 'Split first, decide everything else downstream of the split.'</a:t>
             </a:r>
           </a:p>
         </p:txBody>
@@ -3587,7 +3586,7 @@
           <a:p>
             <a:r>
               <a:rPr lang="en-US" dirty="0"/>
-              <a:t>4 min. Order of operations is a scientific commitment: lock question &amp; label; split first; everything data-dependent happens inside training only; touch the test set once at the end. 'Split first, decide everything else downstream of the split.'</a:t>
+              <a:t>4 min. Train fits the model. Validation tunes choices (used many times). Test estimates real-world performance (used once, never for decisions). In small cohorts, cross-validation replaces a fixed validation set (preview).</a:t>
             </a:r>
           </a:p>
         </p:txBody>
@@ -3674,7 +3673,7 @@
           <a:p>
             <a:r>
               <a:rPr lang="en-US" dirty="0"/>
-              <a:t>4 min. Train fits the model. Validation tunes choices (used many times). Test estimates real-world performance (used once, never for decisions). In small cohorts, cross-validation replaces a fixed validation set (preview).</a:t>
+              <a:t>4 min. Split by patient not sample. Respect batch — don't separate batches by outcome. Stratify for class balance (relapses are a minority). Gold standard: an independent external cohort, ideally another institution/platform.</a:t>
             </a:r>
           </a:p>
         </p:txBody>
@@ -3761,7 +3760,7 @@
           <a:p>
             <a:r>
               <a:rPr lang="en-US" dirty="0"/>
-              <a:t>4 min. Split by patient not sample. Respect batch — don't separate batches by outcome. Stratify for class balance (relapses are a minority). Gold standard: an independent external cohort, ideally another institution/platform.</a:t>
+              <a:t>2 min. Land the thesis. A simple model on a clean pipeline beats a fancy model on a compromised one, every time.</a:t>
             </a:r>
           </a:p>
         </p:txBody>
@@ -3848,7 +3847,7 @@
           <a:p>
             <a:r>
               <a:rPr lang="en-US" dirty="0"/>
-              <a:t>2 min. Land the thesis. A simple model on a clean pipeline beats a fancy model on a compromised one, every time.</a:t>
+              <a:t>2 min. Tick the objectives. Preview the practical: load METABRIC + GSE6532, derive a binary relapse label, check class balance, run PCA, hunt the cross-platform batch effect, build a patient-level stratified batch-aware split. Next lecture: our first models.</a:t>
             </a:r>
           </a:p>
         </p:txBody>
@@ -3871,93 +3870,6 @@
             <a:fld id="{F7021451-1387-4CA6-816F-3879F97B5CBC}" type="slidenum">
               <a:rPr lang="en-US"/>
               <a:t>24</a:t>
-            </a:fld>
-            <a:endParaRPr lang="en-US"/>
-          </a:p>
-        </p:txBody>
-      </p:sp>
-    </p:spTree>
-    <p:extLst>
-      <p:ext uri="{BB962C8B-B14F-4D97-AF65-F5344CB8AC3E}">
-        <p14:creationId xmlns:p14="http://schemas.microsoft.com/office/powerpoint/2010/main" val="1024086991"/>
-      </p:ext>
-    </p:extLst>
-  </p:cSld>
-  <p:clrMapOvr>
-    <a:masterClrMapping/>
-  </p:clrMapOvr>
-</p:notes>
-</file>
-
-<file path=ppt/notesSlides/notesSlide25.xml><?xml version="1.0" encoding="utf-8"?>
-<p:notes xmlns:a="http://schemas.openxmlformats.org/drawingml/2006/main" xmlns:r="http://schemas.openxmlformats.org/officeDocument/2006/relationships" xmlns:p="http://schemas.openxmlformats.org/presentationml/2006/main">
-  <p:cSld>
-    <p:spTree>
-      <p:nvGrpSpPr>
-        <p:cNvPr id="1" name=""/>
-        <p:cNvGrpSpPr/>
-        <p:nvPr/>
-      </p:nvGrpSpPr>
-      <p:grpSpPr>
-        <a:xfrm>
-          <a:off x="0" y="0"/>
-          <a:ext cx="0" cy="0"/>
-          <a:chOff x="0" y="0"/>
-          <a:chExt cx="0" cy="0"/>
-        </a:xfrm>
-      </p:grpSpPr>
-      <p:sp>
-        <p:nvSpPr>
-          <p:cNvPr id="2" name="Slide Image Placeholder 1"/>
-          <p:cNvSpPr>
-            <a:spLocks noGrp="1" noRot="1" noChangeAspect="1"/>
-          </p:cNvSpPr>
-          <p:nvPr>
-            <p:ph type="sldImg"/>
-          </p:nvPr>
-        </p:nvSpPr>
-        <p:spPr/>
-      </p:sp>
-      <p:sp>
-        <p:nvSpPr>
-          <p:cNvPr id="3" name="Notes Placeholder 2"/>
-          <p:cNvSpPr>
-            <a:spLocks noGrp="1"/>
-          </p:cNvSpPr>
-          <p:nvPr>
-            <p:ph type="body" idx="1"/>
-          </p:nvPr>
-        </p:nvSpPr>
-        <p:spPr/>
-        <p:txBody>
-          <a:bodyPr/>
-          <a:lstStyle/>
-          <a:p>
-            <a:r>
-              <a:rPr lang="en-US" dirty="0"/>
-              <a:t>2 min. Tick the objectives. Preview the practical: load METABRIC + GSE6532, derive a binary relapse label, check class balance, run PCA, hunt the cross-platform batch effect, build a patient-level stratified batch-aware split. Next lecture: our first models.</a:t>
-            </a:r>
-          </a:p>
-        </p:txBody>
-      </p:sp>
-      <p:sp>
-        <p:nvSpPr>
-          <p:cNvPr id="4" name="Slide Number Placeholder 3"/>
-          <p:cNvSpPr>
-            <a:spLocks noGrp="1"/>
-          </p:cNvSpPr>
-          <p:nvPr>
-            <p:ph type="sldNum" sz="quarter" idx="10"/>
-          </p:nvPr>
-        </p:nvSpPr>
-        <p:spPr/>
-        <p:txBody>
-          <a:bodyPr/>
-          <a:lstStyle/>
-          <a:p>
-            <a:fld id="{F7021451-1387-4CA6-816F-3879F97B5CBC}" type="slidenum">
-              <a:rPr lang="en-US"/>
-              <a:t>25</a:t>
             </a:fld>
             <a:endParaRPr lang="en-US"/>
           </a:p>
@@ -9733,9 +9645,8 @@
                 <a:ea typeface="Calibri" pitchFamily="34" charset="-122"/>
                 <a:cs typeface="Calibri" pitchFamily="34" charset="-120"/>
               </a:rPr>
-              <a:t>Far more features (p ≈ 20,000) than samples (n ≈ hundreds to low thousands).</a:t>
-            </a:r>
-            <a:endParaRPr lang="en-US" sz="1600" dirty="0"/>
+              <a:t>Transcriptomics: lot of information (regulatory network, proxy for genetic events and so on) summarized in 20k gene expression</a:t>
+            </a:r>
           </a:p>
           <a:p>
             <a:pPr marL="203200" indent="-203200">
@@ -9754,7 +9665,7 @@
                 <a:ea typeface="Calibri" pitchFamily="34" charset="-122"/>
                 <a:cs typeface="Calibri" pitchFamily="34" charset="-120"/>
               </a:rPr>
-              <a:t>This is the defining property of transcriptomic ML: p ≫ n — true even for a large cohort like METABRIC (~1,400 HR+/HER2− still ≪ 20,000 genes).</a:t>
+              <a:t>Far more features (p ≈ 20,000) than samples (n ≈ hundreds to low thousands).</a:t>
             </a:r>
             <a:endParaRPr lang="en-US" sz="1600" dirty="0"/>
           </a:p>
@@ -9775,7 +9686,7 @@
                 <a:ea typeface="Calibri" pitchFamily="34" charset="-122"/>
                 <a:cs typeface="Calibri" pitchFamily="34" charset="-120"/>
               </a:rPr>
-              <a:t>Contrast with classic ML, where n ≫ p.</a:t>
+              <a:t>This is the defining property of transcriptomic ML: p ≫ n, true even for a large cohort like METABRIC (~1,400 HR+/HER2− still ≪ 20,000 genes).</a:t>
             </a:r>
             <a:endParaRPr lang="en-US" sz="1600" dirty="0"/>
           </a:p>
@@ -9788,15 +9699,55 @@
               <a:buChar char="•"/>
             </a:pPr>
             <a:r>
-              <a:rPr lang="en-US" sz="1600" b="1" dirty="0">
-                <a:solidFill>
-                  <a:srgbClr val="0E7C86"/>
+              <a:rPr lang="en-US" sz="1600" dirty="0">
+                <a:solidFill>
+                  <a:srgbClr val="12262B"/>
                 </a:solidFill>
                 <a:latin typeface="Calibri" pitchFamily="34" charset="0"/>
                 <a:ea typeface="Calibri" pitchFamily="34" charset="-122"/>
                 <a:cs typeface="Calibri" pitchFamily="34" charset="-120"/>
               </a:rPr>
-              <a:t>Consequence: the data are “short and fat,” and short-fat data behave counterintuitively.</a:t>
+              <a:t>Contrast with classic ML, where n ≫ p.</a:t>
+            </a:r>
+            <a:endParaRPr lang="en-US" sz="1600" dirty="0"/>
+          </a:p>
+          <a:p>
+            <a:pPr marL="203200" indent="-203200">
+              <a:spcAft>
+                <a:spcPts val="1400"/>
+              </a:spcAft>
+              <a:buSzPct val="100000"/>
+              <a:buChar char="•"/>
+            </a:pPr>
+            <a:r>
+              <a:rPr lang="en-US" sz="1600" b="1" dirty="0">
+                <a:solidFill>
+                  <a:srgbClr val="0E7C86"/>
+                </a:solidFill>
+                <a:latin typeface="Calibri" pitchFamily="34" charset="0"/>
+                <a:ea typeface="Calibri" pitchFamily="34" charset="-122"/>
+                <a:cs typeface="Calibri" pitchFamily="34" charset="-120"/>
+              </a:rPr>
+              <a:t>Consequence: the data are “short and fat,” and short-fat data behave counterintuitively: overfitting is just around the corner</a:t>
+            </a:r>
+          </a:p>
+          <a:p>
+            <a:pPr marL="203200" indent="-203200">
+              <a:spcAft>
+                <a:spcPts val="1400"/>
+              </a:spcAft>
+              <a:buSzPct val="100000"/>
+              <a:buChar char="•"/>
+            </a:pPr>
+            <a:r>
+              <a:rPr lang="en-US" sz="1600" b="1" dirty="0">
+                <a:solidFill>
+                  <a:srgbClr val="0E7C86"/>
+                </a:solidFill>
+                <a:latin typeface="Calibri" pitchFamily="34" charset="0"/>
+                <a:cs typeface="Calibri" pitchFamily="34" charset="-120"/>
+              </a:rPr>
+              <a:t>QUESTION: how many samples such that 20k feature would not be dangerous?</a:t>
             </a:r>
             <a:endParaRPr lang="en-US" sz="1600" dirty="0"/>
           </a:p>
@@ -10325,6 +10276,54 @@
               </a:rPr>
               <a:t>This is why high-dimensional data make overfitting the default, not the exception.</a:t>
             </a:r>
+          </a:p>
+          <a:p>
+            <a:pPr marL="203200" indent="-203200">
+              <a:spcAft>
+                <a:spcPts val="1400"/>
+              </a:spcAft>
+              <a:buSzPct val="100000"/>
+              <a:buFontTx/>
+              <a:buChar char="•"/>
+            </a:pPr>
+            <a:r>
+              <a:rPr lang="en-US" sz="1600" dirty="0">
+                <a:solidFill>
+                  <a:srgbClr val="0E7C86"/>
+                </a:solidFill>
+                <a:latin typeface="Calibri" pitchFamily="34" charset="0"/>
+                <a:ea typeface="Calibri" pitchFamily="34" charset="-122"/>
+                <a:cs typeface="Calibri" pitchFamily="34" charset="-120"/>
+              </a:rPr>
+              <a:t>QUESTION: if the model perfectly separates the classes, does this imply that the model learned biology?</a:t>
+            </a:r>
+            <a:endParaRPr lang="en-US" sz="1600" dirty="0"/>
+          </a:p>
+          <a:p>
+            <a:pPr marL="203200" indent="-203200">
+              <a:spcAft>
+                <a:spcPts val="1400"/>
+              </a:spcAft>
+              <a:buSzPct val="100000"/>
+              <a:buChar char="•"/>
+            </a:pPr>
+            <a:endParaRPr lang="en-US" sz="1600" dirty="0">
+              <a:solidFill>
+                <a:srgbClr val="12262B"/>
+              </a:solidFill>
+              <a:latin typeface="Calibri" pitchFamily="34" charset="0"/>
+              <a:ea typeface="Calibri" pitchFamily="34" charset="-122"/>
+              <a:cs typeface="Calibri" pitchFamily="34" charset="-120"/>
+            </a:endParaRPr>
+          </a:p>
+          <a:p>
+            <a:pPr marL="203200" indent="-203200">
+              <a:spcAft>
+                <a:spcPts val="1400"/>
+              </a:spcAft>
+              <a:buSzPct val="100000"/>
+              <a:buChar char="•"/>
+            </a:pPr>
             <a:endParaRPr lang="en-US" sz="1600" dirty="0"/>
           </a:p>
         </p:txBody>
@@ -12045,7 +12044,7 @@
                 <a:ea typeface="Calibri" pitchFamily="34" charset="-122"/>
                 <a:cs typeface="Calibri" pitchFamily="34" charset="-120"/>
               </a:rPr>
-              <a:t>In p ≫ n it is trivially easy: more knobs than data points.</a:t>
+              <a:t>In p ≫ n it is trivially easy.</a:t>
             </a:r>
             <a:endParaRPr lang="en-US" sz="1600" dirty="0"/>
           </a:p>
@@ -12088,6 +12087,25 @@
                 <a:cs typeface="Calibri" pitchFamily="34" charset="-120"/>
               </a:rPr>
               <a:t>“With enough genes, you can fit the noise in your sample as confidently as the signal.”</a:t>
+            </a:r>
+          </a:p>
+          <a:p>
+            <a:pPr marL="203200" indent="-203200">
+              <a:spcAft>
+                <a:spcPts val="1400"/>
+              </a:spcAft>
+              <a:buSzPct val="100000"/>
+              <a:buChar char="•"/>
+            </a:pPr>
+            <a:r>
+              <a:rPr lang="en-US" sz="1600" dirty="0">
+                <a:solidFill>
+                  <a:srgbClr val="0E7C86"/>
+                </a:solidFill>
+                <a:latin typeface="Calibri" pitchFamily="34" charset="0"/>
+                <a:cs typeface="Calibri" pitchFamily="34" charset="-120"/>
+              </a:rPr>
+              <a:t>QUESTION: What would actually convince you that a model learned biology, not noise?</a:t>
             </a:r>
             <a:endParaRPr lang="en-US" sz="1600" dirty="0"/>
           </a:p>
@@ -12356,7 +12374,7 @@
                 <a:ea typeface="Calibri" pitchFamily="34" charset="-122"/>
                 <a:cs typeface="Calibri" pitchFamily="34" charset="-120"/>
               </a:rPr>
-              <a:t>Published signatures are often unstable — resampling patients changes which genes are selected.</a:t>
+              <a:t>Published signatures are often unstable: resampling patients changes which genes are selected.</a:t>
             </a:r>
             <a:endParaRPr lang="en-US" sz="1600" dirty="0"/>
           </a:p>
@@ -12400,6 +12418,53 @@
               </a:rPr>
               <a:t>This is a feature of p ≫ n, not a flaw in any one study.</a:t>
             </a:r>
+          </a:p>
+          <a:p>
+            <a:pPr marL="203200" indent="-203200">
+              <a:spcAft>
+                <a:spcPts val="1400"/>
+              </a:spcAft>
+              <a:buSzPct val="100000"/>
+              <a:buFontTx/>
+              <a:buChar char="•"/>
+            </a:pPr>
+            <a:r>
+              <a:rPr lang="en-US" sz="1600" dirty="0">
+                <a:solidFill>
+                  <a:srgbClr val="0E7C86"/>
+                </a:solidFill>
+                <a:latin typeface="Calibri" pitchFamily="34" charset="0"/>
+                <a:cs typeface="Calibri" pitchFamily="34" charset="-120"/>
+              </a:rPr>
+              <a:t>QUESTION: how do we avoid randomness and pick at least weak evidence? </a:t>
+            </a:r>
+            <a:endParaRPr lang="en-US" sz="1600" dirty="0"/>
+          </a:p>
+          <a:p>
+            <a:pPr marL="203200" indent="-203200">
+              <a:spcAft>
+                <a:spcPts val="1400"/>
+              </a:spcAft>
+              <a:buSzPct val="100000"/>
+              <a:buChar char="•"/>
+            </a:pPr>
+            <a:endParaRPr lang="en-US" sz="1600" dirty="0">
+              <a:solidFill>
+                <a:srgbClr val="12262B"/>
+              </a:solidFill>
+              <a:latin typeface="Calibri" pitchFamily="34" charset="0"/>
+              <a:ea typeface="Calibri" pitchFamily="34" charset="-122"/>
+              <a:cs typeface="Calibri" pitchFamily="34" charset="-120"/>
+            </a:endParaRPr>
+          </a:p>
+          <a:p>
+            <a:pPr marL="203200" indent="-203200">
+              <a:spcAft>
+                <a:spcPts val="1400"/>
+              </a:spcAft>
+              <a:buSzPct val="100000"/>
+              <a:buChar char="•"/>
+            </a:pPr>
             <a:endParaRPr lang="en-US" sz="1600" dirty="0"/>
           </a:p>
         </p:txBody>
@@ -12884,7 +12949,7 @@
                 <a:ea typeface="Calibri" pitchFamily="34" charset="-122"/>
                 <a:cs typeface="Calibri" pitchFamily="34" charset="-120"/>
               </a:rPr>
-              <a:t>Batch effect = systematic technical variation tied to when / where / how samples were processed (run date, machine, technician, reagent lot, hospital, platform).</a:t>
+              <a:t>Batch effect = systematic technical variation linked to when / where / how / who processed the samples (run date, machine, technician, reagent lot, hospital, platform).</a:t>
             </a:r>
             <a:endParaRPr lang="en-US" sz="1600" dirty="0"/>
           </a:p>
@@ -12927,6 +12992,41 @@
                 <a:cs typeface="Calibri" pitchFamily="34" charset="-120"/>
               </a:rPr>
               <a:t>Danger: if batch correlates with outcome (e.g. all relapses processed at one site), the model learns the batch, not the biology.</a:t>
+            </a:r>
+          </a:p>
+          <a:p>
+            <a:pPr marL="203200" indent="-203200">
+              <a:spcAft>
+                <a:spcPts val="1400"/>
+              </a:spcAft>
+              <a:buSzPct val="100000"/>
+              <a:buChar char="•"/>
+            </a:pPr>
+            <a:r>
+              <a:rPr lang="en-US" sz="1600" dirty="0">
+                <a:latin typeface="Calibri" pitchFamily="34" charset="0"/>
+                <a:cs typeface="Calibri" pitchFamily="34" charset="-120"/>
+              </a:rPr>
+              <a:t>Imagine: all responders are from A and all no responder are from B (or enrichment)!</a:t>
+            </a:r>
+          </a:p>
+          <a:p>
+            <a:pPr marL="203200" indent="-203200">
+              <a:spcAft>
+                <a:spcPts val="1400"/>
+              </a:spcAft>
+              <a:buSzPct val="100000"/>
+              <a:buChar char="•"/>
+            </a:pPr>
+            <a:r>
+              <a:rPr lang="en-US" sz="1600" b="1" dirty="0">
+                <a:solidFill>
+                  <a:srgbClr val="C2772B"/>
+                </a:solidFill>
+                <a:latin typeface="Calibri" pitchFamily="34" charset="0"/>
+                <a:cs typeface="Calibri" pitchFamily="34" charset="-120"/>
+              </a:rPr>
+              <a:t>REMEMBER: standard normalization does not necessary correct for batch effect</a:t>
             </a:r>
             <a:endParaRPr lang="en-US" sz="1600" dirty="0"/>
           </a:p>
@@ -13290,7 +13390,7 @@
         </p:nvSpPr>
         <p:spPr>
           <a:xfrm flipV="1">
-            <a:off x="8778240" y="3931920"/>
+            <a:off x="8778240" y="3561588"/>
             <a:ext cx="640080" cy="640080"/>
           </a:xfrm>
           <a:prstGeom prst="line">
@@ -13542,7 +13642,7 @@
         </p:nvSpPr>
         <p:spPr>
           <a:xfrm>
-            <a:off x="548640" y="1828800"/>
+            <a:off x="563880" y="1499616"/>
             <a:ext cx="11064240" cy="1005840"/>
           </a:xfrm>
           <a:prstGeom prst="rect">
@@ -13613,9 +13713,76 @@
                 <a:ea typeface="Calibri" pitchFamily="34" charset="-122"/>
                 <a:cs typeface="Calibri" pitchFamily="34" charset="-120"/>
               </a:rPr>
-              <a:t>A diagnostic, not a fix — correction (e.g. ComBat) comes later and has its own pitfalls.</a:t>
-            </a:r>
-            <a:endParaRPr lang="en-US" sz="1500" dirty="0"/>
+              <a:t>A diagnostic, not a fix: correction (e.g. </a:t>
+            </a:r>
+            <a:r>
+              <a:rPr lang="en-US" sz="1500" dirty="0" err="1">
+                <a:solidFill>
+                  <a:srgbClr val="12262B"/>
+                </a:solidFill>
+                <a:latin typeface="Calibri" pitchFamily="34" charset="0"/>
+                <a:ea typeface="Calibri" pitchFamily="34" charset="-122"/>
+                <a:cs typeface="Calibri" pitchFamily="34" charset="-120"/>
+              </a:rPr>
+              <a:t>ComBat</a:t>
+            </a:r>
+            <a:r>
+              <a:rPr lang="en-US" sz="1500" dirty="0">
+                <a:solidFill>
+                  <a:srgbClr val="12262B"/>
+                </a:solidFill>
+                <a:latin typeface="Calibri" pitchFamily="34" charset="0"/>
+                <a:ea typeface="Calibri" pitchFamily="34" charset="-122"/>
+                <a:cs typeface="Calibri" pitchFamily="34" charset="-120"/>
+              </a:rPr>
+              <a:t>, quantile </a:t>
+            </a:r>
+            <a:r>
+              <a:rPr lang="en-US" sz="1500" dirty="0" err="1">
+                <a:solidFill>
+                  <a:srgbClr val="12262B"/>
+                </a:solidFill>
+                <a:latin typeface="Calibri" pitchFamily="34" charset="0"/>
+                <a:ea typeface="Calibri" pitchFamily="34" charset="-122"/>
+                <a:cs typeface="Calibri" pitchFamily="34" charset="-120"/>
+              </a:rPr>
+              <a:t>normalisation</a:t>
+            </a:r>
+            <a:r>
+              <a:rPr lang="en-US" sz="1500" dirty="0">
+                <a:solidFill>
+                  <a:srgbClr val="12262B"/>
+                </a:solidFill>
+                <a:latin typeface="Calibri" pitchFamily="34" charset="0"/>
+                <a:ea typeface="Calibri" pitchFamily="34" charset="-122"/>
+                <a:cs typeface="Calibri" pitchFamily="34" charset="-120"/>
+              </a:rPr>
+              <a:t>) comes later and must done carefully to avoid data leakage!</a:t>
+            </a:r>
+          </a:p>
+          <a:p>
+            <a:pPr marL="203200" indent="-203200">
+              <a:spcAft>
+                <a:spcPts val="800"/>
+              </a:spcAft>
+              <a:buSzPct val="100000"/>
+              <a:buChar char="•"/>
+            </a:pPr>
+            <a:r>
+              <a:rPr lang="en-US" sz="1500" dirty="0">
+                <a:solidFill>
+                  <a:srgbClr val="00B0F0"/>
+                </a:solidFill>
+                <a:latin typeface="Calibri" pitchFamily="34" charset="0"/>
+                <a:cs typeface="Calibri" pitchFamily="34" charset="-120"/>
+              </a:rPr>
+              <a:t>QUESTION: Suppose PC1 perfectly separates two hospitals, and all your responders happen to be in one. Can you still correct for batch?</a:t>
+            </a:r>
+            <a:endParaRPr lang="en-US" sz="1500" dirty="0">
+              <a:solidFill>
+                <a:srgbClr val="00B0F0"/>
+              </a:solidFill>
+            </a:endParaRPr>
           </a:p>
         </p:txBody>
       </p:sp>
@@ -13916,7 +14083,7 @@
                 <a:ea typeface="Calibri" pitchFamily="34" charset="-122"/>
                 <a:cs typeface="Calibri" pitchFamily="34" charset="-120"/>
               </a:rPr>
-              <a:t>Leakage = information from outside the training set sneaks into model building.</a:t>
+              <a:t>Leakage = information from outside the training set (e.g. hold out test set) sneaks into model building.</a:t>
             </a:r>
             <a:endParaRPr lang="en-US" sz="1600" dirty="0"/>
           </a:p>
@@ -13980,6 +14147,25 @@
                 <a:cs typeface="Calibri" pitchFamily="34" charset="-120"/>
               </a:rPr>
               <a:t>Today we recognise leakage; later we prevent it systematically.</a:t>
+            </a:r>
+          </a:p>
+          <a:p>
+            <a:pPr marL="203200" indent="-203200">
+              <a:spcAft>
+                <a:spcPts val="1400"/>
+              </a:spcAft>
+              <a:buSzPct val="100000"/>
+              <a:buChar char="•"/>
+            </a:pPr>
+            <a:r>
+              <a:rPr lang="en-US" sz="1600" b="1" dirty="0">
+                <a:solidFill>
+                  <a:srgbClr val="0E7C86"/>
+                </a:solidFill>
+                <a:latin typeface="Calibri" pitchFamily="34" charset="0"/>
+                <a:cs typeface="Calibri" pitchFamily="34" charset="-120"/>
+              </a:rPr>
+              <a:t>Leakage is very often a mistake in the conceptual design, not coding error</a:t>
             </a:r>
             <a:endParaRPr lang="en-US" sz="1600" dirty="0"/>
           </a:p>
@@ -15041,7 +15227,29 @@
                 <a:ea typeface="Calibri" pitchFamily="34" charset="-122"/>
                 <a:cs typeface="Calibri" pitchFamily="34" charset="-120"/>
               </a:rPr>
-              <a:t>Replicates or multiple biopsies from one patient split across train and test.</a:t>
+              <a:t>Replicates or multiple biopsies from one patient split across train and test. Longitudinal data of same patient </a:t>
+            </a:r>
+            <a:r>
+              <a:rPr lang="en-US" sz="1300" dirty="0" err="1">
+                <a:solidFill>
+                  <a:srgbClr val="5B6B70"/>
+                </a:solidFill>
+                <a:latin typeface="Calibri" pitchFamily="34" charset="0"/>
+                <a:ea typeface="Calibri" pitchFamily="34" charset="-122"/>
+                <a:cs typeface="Calibri" pitchFamily="34" charset="-120"/>
+              </a:rPr>
+              <a:t>splitted</a:t>
+            </a:r>
+            <a:r>
+              <a:rPr lang="en-US" sz="1300" dirty="0">
+                <a:solidFill>
+                  <a:srgbClr val="5B6B70"/>
+                </a:solidFill>
+                <a:latin typeface="Calibri" pitchFamily="34" charset="0"/>
+                <a:ea typeface="Calibri" pitchFamily="34" charset="-122"/>
+                <a:cs typeface="Calibri" pitchFamily="34" charset="-120"/>
+              </a:rPr>
+              <a:t> across train test</a:t>
             </a:r>
             <a:endParaRPr lang="en-US" sz="1300" dirty="0"/>
           </a:p>
@@ -15195,7 +15403,7 @@
                 <a:ea typeface="Cambria" pitchFamily="34" charset="-122"/>
                 <a:cs typeface="Cambria" pitchFamily="34" charset="-120"/>
               </a:rPr>
-              <a:t>Temporal / label leakage</a:t>
+              <a:t>Hidden leakage</a:t>
             </a:r>
             <a:endParaRPr lang="en-US" sz="1600" dirty="0"/>
           </a:p>
@@ -15234,7 +15442,7 @@
                 <a:ea typeface="Calibri" pitchFamily="34" charset="-122"/>
                 <a:cs typeface="Calibri" pitchFamily="34" charset="-120"/>
               </a:rPr>
-              <a:t>Using information only available after the outcome is known.</a:t>
+              <a:t>Using published signatures extracted from the cohort you are using to develop the model!</a:t>
             </a:r>
             <a:endParaRPr lang="en-US" sz="1300" dirty="0"/>
           </a:p>
@@ -15249,722 +15457,6 @@
 </file>
 
 <file path=ppt/slides/slide18.xml><?xml version="1.0" encoding="utf-8"?>
-<p:sld xmlns:a="http://schemas.openxmlformats.org/drawingml/2006/main" xmlns:r="http://schemas.openxmlformats.org/officeDocument/2006/relationships" xmlns:p="http://schemas.openxmlformats.org/presentationml/2006/main">
-  <p:cSld name="Slide 18">
-    <p:bg>
-      <p:bgPr>
-        <a:solidFill>
-          <a:srgbClr val="FFFFFF"/>
-        </a:solidFill>
-        <a:effectLst/>
-      </p:bgPr>
-    </p:bg>
-    <p:spTree>
-      <p:nvGrpSpPr>
-        <p:cNvPr id="1" name=""/>
-        <p:cNvGrpSpPr/>
-        <p:nvPr/>
-      </p:nvGrpSpPr>
-      <p:grpSpPr>
-        <a:xfrm>
-          <a:off x="0" y="0"/>
-          <a:ext cx="0" cy="0"/>
-          <a:chOff x="0" y="0"/>
-          <a:chExt cx="0" cy="0"/>
-        </a:xfrm>
-      </p:grpSpPr>
-      <p:sp>
-        <p:nvSpPr>
-          <p:cNvPr id="2" name="Text 0"/>
-          <p:cNvSpPr/>
-          <p:nvPr/>
-        </p:nvSpPr>
-        <p:spPr>
-          <a:xfrm>
-            <a:off x="548640" y="384048"/>
-            <a:ext cx="10515600" cy="274320"/>
-          </a:xfrm>
-          <a:prstGeom prst="rect">
-            <a:avLst/>
-          </a:prstGeom>
-          <a:noFill/>
-          <a:ln/>
-        </p:spPr>
-        <p:txBody>
-          <a:bodyPr wrap="square" lIns="0" tIns="0" rIns="0" bIns="0" rtlCol="0" anchor="ctr"/>
-          <a:lstStyle/>
-          <a:p>
-            <a:pPr marL="0" indent="0">
-              <a:buNone/>
-            </a:pPr>
-            <a:r>
-              <a:rPr lang="en-US" sz="1200" b="1" kern="0" spc="200" dirty="0">
-                <a:solidFill>
-                  <a:srgbClr val="0E7C86"/>
-                </a:solidFill>
-                <a:latin typeface="Calibri" pitchFamily="34" charset="0"/>
-                <a:ea typeface="Calibri" pitchFamily="34" charset="-122"/>
-                <a:cs typeface="Calibri" pitchFamily="34" charset="-120"/>
-              </a:rPr>
-              <a:t>CASE STUDY</a:t>
-            </a:r>
-            <a:endParaRPr lang="en-US" sz="1200" dirty="0"/>
-          </a:p>
-        </p:txBody>
-      </p:sp>
-      <p:sp>
-        <p:nvSpPr>
-          <p:cNvPr id="3" name="Text 1"/>
-          <p:cNvSpPr/>
-          <p:nvPr/>
-        </p:nvSpPr>
-        <p:spPr>
-          <a:xfrm>
-            <a:off x="548640" y="658368"/>
-            <a:ext cx="11064240" cy="868680"/>
-          </a:xfrm>
-          <a:prstGeom prst="rect">
-            <a:avLst/>
-          </a:prstGeom>
-          <a:noFill/>
-          <a:ln/>
-        </p:spPr>
-        <p:txBody>
-          <a:bodyPr wrap="square" lIns="0" tIns="0" rIns="0" bIns="0" rtlCol="0" anchor="t"/>
-          <a:lstStyle/>
-          <a:p>
-            <a:pPr marL="0" indent="0">
-              <a:buNone/>
-            </a:pPr>
-            <a:r>
-              <a:rPr lang="en-US" sz="3000" b="1" dirty="0">
-                <a:solidFill>
-                  <a:srgbClr val="12262B"/>
-                </a:solidFill>
-                <a:latin typeface="Cambria" pitchFamily="34" charset="0"/>
-                <a:ea typeface="Cambria" pitchFamily="34" charset="-122"/>
-                <a:cs typeface="Cambria" pitchFamily="34" charset="-120"/>
-              </a:rPr>
-              <a:t>When a biomarker collapses: Duke / Potti</a:t>
-            </a:r>
-            <a:endParaRPr lang="en-US" sz="3000" dirty="0"/>
-          </a:p>
-        </p:txBody>
-      </p:sp>
-      <p:sp>
-        <p:nvSpPr>
-          <p:cNvPr id="4" name="Text 2"/>
-          <p:cNvSpPr/>
-          <p:nvPr/>
-        </p:nvSpPr>
-        <p:spPr>
-          <a:xfrm>
-            <a:off x="548640" y="6473952"/>
-            <a:ext cx="7315200" cy="274320"/>
-          </a:xfrm>
-          <a:prstGeom prst="rect">
-            <a:avLst/>
-          </a:prstGeom>
-          <a:noFill/>
-          <a:ln/>
-        </p:spPr>
-        <p:txBody>
-          <a:bodyPr wrap="square" lIns="0" tIns="0" rIns="0" bIns="0" rtlCol="0" anchor="ctr"/>
-          <a:lstStyle/>
-          <a:p>
-            <a:pPr marL="0" indent="0">
-              <a:buNone/>
-            </a:pPr>
-            <a:r>
-              <a:rPr lang="en-US" sz="900" dirty="0">
-                <a:solidFill>
-                  <a:srgbClr val="5B6B70"/>
-                </a:solidFill>
-                <a:latin typeface="Calibri" pitchFamily="34" charset="0"/>
-                <a:ea typeface="Calibri" pitchFamily="34" charset="-122"/>
-                <a:cs typeface="Calibri" pitchFamily="34" charset="-120"/>
-              </a:rPr>
-              <a:t>Practical ML for Transcriptomics  ·  Lecture 1</a:t>
-            </a:r>
-            <a:endParaRPr lang="en-US" sz="900" dirty="0"/>
-          </a:p>
-        </p:txBody>
-      </p:sp>
-      <p:sp>
-        <p:nvSpPr>
-          <p:cNvPr id="5" name="Text 3"/>
-          <p:cNvSpPr/>
-          <p:nvPr/>
-        </p:nvSpPr>
-        <p:spPr>
-          <a:xfrm>
-            <a:off x="11247120" y="6473952"/>
-            <a:ext cx="365760" cy="274320"/>
-          </a:xfrm>
-          <a:prstGeom prst="rect">
-            <a:avLst/>
-          </a:prstGeom>
-          <a:noFill/>
-          <a:ln/>
-        </p:spPr>
-        <p:txBody>
-          <a:bodyPr wrap="square" lIns="0" tIns="0" rIns="0" bIns="0" rtlCol="0" anchor="ctr"/>
-          <a:lstStyle/>
-          <a:p>
-            <a:pPr marL="0" indent="0" algn="r">
-              <a:buNone/>
-            </a:pPr>
-            <a:r>
-              <a:rPr lang="en-US" sz="900" dirty="0">
-                <a:solidFill>
-                  <a:srgbClr val="5B6B70"/>
-                </a:solidFill>
-                <a:latin typeface="Calibri" pitchFamily="34" charset="0"/>
-                <a:ea typeface="Calibri" pitchFamily="34" charset="-122"/>
-                <a:cs typeface="Calibri" pitchFamily="34" charset="-120"/>
-              </a:rPr>
-              <a:t>18</a:t>
-            </a:r>
-            <a:endParaRPr lang="en-US" sz="900" dirty="0"/>
-          </a:p>
-        </p:txBody>
-      </p:sp>
-      <p:sp>
-        <p:nvSpPr>
-          <p:cNvPr id="7" name="Text 4"/>
-          <p:cNvSpPr/>
-          <p:nvPr/>
-        </p:nvSpPr>
-        <p:spPr>
-          <a:xfrm>
-            <a:off x="548640" y="1828800"/>
-            <a:ext cx="11064240" cy="1554480"/>
-          </a:xfrm>
-          <a:prstGeom prst="rect">
-            <a:avLst/>
-          </a:prstGeom>
-          <a:noFill/>
-          <a:ln/>
-        </p:spPr>
-        <p:txBody>
-          <a:bodyPr wrap="square" lIns="0" tIns="0" rIns="0" bIns="0" rtlCol="0" anchor="t"/>
-          <a:lstStyle/>
-          <a:p>
-            <a:pPr marL="203200" indent="-203200">
-              <a:spcAft>
-                <a:spcPts val="900"/>
-              </a:spcAft>
-              <a:buSzPct val="100000"/>
-              <a:buChar char="•"/>
-            </a:pPr>
-            <a:r>
-              <a:rPr lang="en-US" sz="1500" dirty="0">
-                <a:solidFill>
-                  <a:srgbClr val="12262B"/>
-                </a:solidFill>
-                <a:latin typeface="Calibri" pitchFamily="34" charset="0"/>
-                <a:ea typeface="Calibri" pitchFamily="34" charset="-122"/>
-                <a:cs typeface="Calibri" pitchFamily="34" charset="-120"/>
-              </a:rPr>
-              <a:t>Chemosensitivity signatures published in top journals, headed to clinical trials — later retracted amid irreproducibility and data errors.</a:t>
-            </a:r>
-            <a:endParaRPr lang="en-US" sz="1500" dirty="0"/>
-          </a:p>
-          <a:p>
-            <a:pPr marL="203200" indent="-203200">
-              <a:spcAft>
-                <a:spcPts val="900"/>
-              </a:spcAft>
-              <a:buSzPct val="100000"/>
-              <a:buChar char="•"/>
-            </a:pPr>
-            <a:r>
-              <a:rPr lang="en-US" sz="1500" dirty="0">
-                <a:solidFill>
-                  <a:srgbClr val="12262B"/>
-                </a:solidFill>
-                <a:latin typeface="Calibri" pitchFamily="34" charset="0"/>
-                <a:ea typeface="Calibri" pitchFamily="34" charset="-122"/>
-                <a:cs typeface="Calibri" pitchFamily="34" charset="-120"/>
-              </a:rPr>
-              <a:t>Forensic reanalysis (Baggerly &amp; Coombes) could not reproduce the results; trials were suspended.</a:t>
-            </a:r>
-            <a:endParaRPr lang="en-US" sz="1500" dirty="0"/>
-          </a:p>
-          <a:p>
-            <a:pPr marL="203200" indent="-203200">
-              <a:spcAft>
-                <a:spcPts val="900"/>
-              </a:spcAft>
-              <a:buSzPct val="100000"/>
-              <a:buChar char="•"/>
-            </a:pPr>
-            <a:r>
-              <a:rPr lang="en-US" sz="1500" b="1" dirty="0">
-                <a:solidFill>
-                  <a:srgbClr val="C2772B"/>
-                </a:solidFill>
-                <a:latin typeface="Calibri" pitchFamily="34" charset="0"/>
-                <a:ea typeface="Calibri" pitchFamily="34" charset="-122"/>
-                <a:cs typeface="Calibri" pitchFamily="34" charset="-120"/>
-              </a:rPr>
-              <a:t>The lesson is not “those scientists were bad” — the pipeline was undocumented and the failure modes we are discussing were not controlled.</a:t>
-            </a:r>
-            <a:endParaRPr lang="en-US" sz="1500" dirty="0"/>
-          </a:p>
-        </p:txBody>
-      </p:sp>
-      <p:sp>
-        <p:nvSpPr>
-          <p:cNvPr id="8" name="Shape 5"/>
-          <p:cNvSpPr/>
-          <p:nvPr/>
-        </p:nvSpPr>
-        <p:spPr>
-          <a:xfrm>
-            <a:off x="822960" y="4114800"/>
-            <a:ext cx="10515600" cy="0"/>
-          </a:xfrm>
-          <a:prstGeom prst="line">
-            <a:avLst/>
-          </a:prstGeom>
-          <a:noFill/>
-          <a:ln w="25400">
-            <a:solidFill>
-              <a:srgbClr val="C9D7D9"/>
-            </a:solidFill>
-            <a:prstDash val="solid"/>
-          </a:ln>
-        </p:spPr>
-      </p:sp>
-      <p:sp>
-        <p:nvSpPr>
-          <p:cNvPr id="9" name="Shape 6"/>
-          <p:cNvSpPr/>
-          <p:nvPr/>
-        </p:nvSpPr>
-        <p:spPr>
-          <a:xfrm>
-            <a:off x="676656" y="3968496"/>
-            <a:ext cx="292608" cy="292608"/>
-          </a:xfrm>
-          <a:prstGeom prst="ellipse">
-            <a:avLst/>
-          </a:prstGeom>
-          <a:solidFill>
-            <a:srgbClr val="0E7C86"/>
-          </a:solidFill>
-          <a:ln/>
-        </p:spPr>
-      </p:sp>
-      <p:sp>
-        <p:nvSpPr>
-          <p:cNvPr id="10" name="Text 7"/>
-          <p:cNvSpPr/>
-          <p:nvPr/>
-        </p:nvSpPr>
-        <p:spPr>
-          <a:xfrm>
-            <a:off x="-91440" y="2971800"/>
-            <a:ext cx="1828800" cy="822960"/>
-          </a:xfrm>
-          <a:prstGeom prst="rect">
-            <a:avLst/>
-          </a:prstGeom>
-          <a:noFill/>
-          <a:ln/>
-        </p:spPr>
-        <p:txBody>
-          <a:bodyPr wrap="square" lIns="0" tIns="0" rIns="0" bIns="0" rtlCol="0" anchor="b"/>
-          <a:lstStyle/>
-          <a:p>
-            <a:pPr marL="0" indent="0" algn="ctr">
-              <a:buNone/>
-            </a:pPr>
-            <a:r>
-              <a:rPr lang="en-US" sz="1100" b="1" dirty="0">
-                <a:solidFill>
-                  <a:srgbClr val="12262B"/>
-                </a:solidFill>
-                <a:latin typeface="Calibri" pitchFamily="34" charset="0"/>
-                <a:ea typeface="Calibri" pitchFamily="34" charset="-122"/>
-                <a:cs typeface="Calibri" pitchFamily="34" charset="-120"/>
-              </a:rPr>
-              <a:t>High-profile</a:t>
-            </a:r>
-            <a:endParaRPr lang="en-US" sz="1100" dirty="0"/>
-          </a:p>
-          <a:p>
-            <a:pPr marL="0" indent="0" algn="ctr">
-              <a:buNone/>
-            </a:pPr>
-            <a:r>
-              <a:rPr lang="en-US" sz="1100" b="1" dirty="0">
-                <a:solidFill>
-                  <a:srgbClr val="12262B"/>
-                </a:solidFill>
-                <a:latin typeface="Calibri" pitchFamily="34" charset="0"/>
-                <a:ea typeface="Calibri" pitchFamily="34" charset="-122"/>
-                <a:cs typeface="Calibri" pitchFamily="34" charset="-120"/>
-              </a:rPr>
-              <a:t>publications</a:t>
-            </a:r>
-            <a:endParaRPr lang="en-US" sz="1100" dirty="0"/>
-          </a:p>
-        </p:txBody>
-      </p:sp>
-      <p:sp>
-        <p:nvSpPr>
-          <p:cNvPr id="11" name="Shape 8"/>
-          <p:cNvSpPr/>
-          <p:nvPr/>
-        </p:nvSpPr>
-        <p:spPr>
-          <a:xfrm>
-            <a:off x="3305556" y="3968496"/>
-            <a:ext cx="292608" cy="292608"/>
-          </a:xfrm>
-          <a:prstGeom prst="ellipse">
-            <a:avLst/>
-          </a:prstGeom>
-          <a:solidFill>
-            <a:srgbClr val="14A6B0"/>
-          </a:solidFill>
-          <a:ln/>
-        </p:spPr>
-      </p:sp>
-      <p:sp>
-        <p:nvSpPr>
-          <p:cNvPr id="12" name="Text 9"/>
-          <p:cNvSpPr/>
-          <p:nvPr/>
-        </p:nvSpPr>
-        <p:spPr>
-          <a:xfrm>
-            <a:off x="2537460" y="4389120"/>
-            <a:ext cx="1828800" cy="822960"/>
-          </a:xfrm>
-          <a:prstGeom prst="rect">
-            <a:avLst/>
-          </a:prstGeom>
-          <a:noFill/>
-          <a:ln/>
-        </p:spPr>
-        <p:txBody>
-          <a:bodyPr wrap="square" lIns="0" tIns="0" rIns="0" bIns="0" rtlCol="0" anchor="t"/>
-          <a:lstStyle/>
-          <a:p>
-            <a:pPr marL="0" indent="0" algn="ctr">
-              <a:buNone/>
-            </a:pPr>
-            <a:r>
-              <a:rPr lang="en-US" sz="1100" b="1" dirty="0">
-                <a:solidFill>
-                  <a:srgbClr val="12262B"/>
-                </a:solidFill>
-                <a:latin typeface="Calibri" pitchFamily="34" charset="0"/>
-                <a:ea typeface="Calibri" pitchFamily="34" charset="-122"/>
-                <a:cs typeface="Calibri" pitchFamily="34" charset="-120"/>
-              </a:rPr>
-              <a:t>Planned</a:t>
-            </a:r>
-            <a:endParaRPr lang="en-US" sz="1100" dirty="0"/>
-          </a:p>
-          <a:p>
-            <a:pPr marL="0" indent="0" algn="ctr">
-              <a:buNone/>
-            </a:pPr>
-            <a:r>
-              <a:rPr lang="en-US" sz="1100" b="1" dirty="0">
-                <a:solidFill>
-                  <a:srgbClr val="12262B"/>
-                </a:solidFill>
-                <a:latin typeface="Calibri" pitchFamily="34" charset="0"/>
-                <a:ea typeface="Calibri" pitchFamily="34" charset="-122"/>
-                <a:cs typeface="Calibri" pitchFamily="34" charset="-120"/>
-              </a:rPr>
-              <a:t>clinical trials</a:t>
-            </a:r>
-            <a:endParaRPr lang="en-US" sz="1100" dirty="0"/>
-          </a:p>
-        </p:txBody>
-      </p:sp>
-      <p:sp>
-        <p:nvSpPr>
-          <p:cNvPr id="13" name="Shape 10"/>
-          <p:cNvSpPr/>
-          <p:nvPr/>
-        </p:nvSpPr>
-        <p:spPr>
-          <a:xfrm>
-            <a:off x="5934456" y="3968496"/>
-            <a:ext cx="292608" cy="292608"/>
-          </a:xfrm>
-          <a:prstGeom prst="ellipse">
-            <a:avLst/>
-          </a:prstGeom>
-          <a:solidFill>
-            <a:srgbClr val="C2772B"/>
-          </a:solidFill>
-          <a:ln/>
-        </p:spPr>
-      </p:sp>
-      <p:sp>
-        <p:nvSpPr>
-          <p:cNvPr id="14" name="Text 11"/>
-          <p:cNvSpPr/>
-          <p:nvPr/>
-        </p:nvSpPr>
-        <p:spPr>
-          <a:xfrm>
-            <a:off x="5166360" y="2971800"/>
-            <a:ext cx="1828800" cy="822960"/>
-          </a:xfrm>
-          <a:prstGeom prst="rect">
-            <a:avLst/>
-          </a:prstGeom>
-          <a:noFill/>
-          <a:ln/>
-        </p:spPr>
-        <p:txBody>
-          <a:bodyPr wrap="square" lIns="0" tIns="0" rIns="0" bIns="0" rtlCol="0" anchor="b"/>
-          <a:lstStyle/>
-          <a:p>
-            <a:pPr marL="0" indent="0" algn="ctr">
-              <a:buNone/>
-            </a:pPr>
-            <a:r>
-              <a:rPr lang="en-US" sz="1100" b="1" dirty="0">
-                <a:solidFill>
-                  <a:srgbClr val="12262B"/>
-                </a:solidFill>
-                <a:latin typeface="Calibri" pitchFamily="34" charset="0"/>
-                <a:ea typeface="Calibri" pitchFamily="34" charset="-122"/>
-                <a:cs typeface="Calibri" pitchFamily="34" charset="-120"/>
-              </a:rPr>
-              <a:t>Independent</a:t>
-            </a:r>
-            <a:endParaRPr lang="en-US" sz="1100" dirty="0"/>
-          </a:p>
-          <a:p>
-            <a:pPr marL="0" indent="0" algn="ctr">
-              <a:buNone/>
-            </a:pPr>
-            <a:r>
-              <a:rPr lang="en-US" sz="1100" b="1" dirty="0">
-                <a:solidFill>
-                  <a:srgbClr val="12262B"/>
-                </a:solidFill>
-                <a:latin typeface="Calibri" pitchFamily="34" charset="0"/>
-                <a:ea typeface="Calibri" pitchFamily="34" charset="-122"/>
-                <a:cs typeface="Calibri" pitchFamily="34" charset="-120"/>
-              </a:rPr>
-              <a:t>reanalysis fails</a:t>
-            </a:r>
-            <a:endParaRPr lang="en-US" sz="1100" dirty="0"/>
-          </a:p>
-        </p:txBody>
-      </p:sp>
-      <p:sp>
-        <p:nvSpPr>
-          <p:cNvPr id="15" name="Shape 12"/>
-          <p:cNvSpPr/>
-          <p:nvPr/>
-        </p:nvSpPr>
-        <p:spPr>
-          <a:xfrm>
-            <a:off x="8563356" y="3968496"/>
-            <a:ext cx="292608" cy="292608"/>
-          </a:xfrm>
-          <a:prstGeom prst="ellipse">
-            <a:avLst/>
-          </a:prstGeom>
-          <a:solidFill>
-            <a:srgbClr val="C2772B"/>
-          </a:solidFill>
-          <a:ln/>
-        </p:spPr>
-      </p:sp>
-      <p:sp>
-        <p:nvSpPr>
-          <p:cNvPr id="16" name="Text 13"/>
-          <p:cNvSpPr/>
-          <p:nvPr/>
-        </p:nvSpPr>
-        <p:spPr>
-          <a:xfrm>
-            <a:off x="7795260" y="4389120"/>
-            <a:ext cx="1828800" cy="822960"/>
-          </a:xfrm>
-          <a:prstGeom prst="rect">
-            <a:avLst/>
-          </a:prstGeom>
-          <a:noFill/>
-          <a:ln/>
-        </p:spPr>
-        <p:txBody>
-          <a:bodyPr wrap="square" lIns="0" tIns="0" rIns="0" bIns="0" rtlCol="0" anchor="t"/>
-          <a:lstStyle/>
-          <a:p>
-            <a:pPr marL="0" indent="0" algn="ctr">
-              <a:buNone/>
-            </a:pPr>
-            <a:r>
-              <a:rPr lang="en-US" sz="1100" b="1" dirty="0">
-                <a:solidFill>
-                  <a:srgbClr val="12262B"/>
-                </a:solidFill>
-                <a:latin typeface="Calibri" pitchFamily="34" charset="0"/>
-                <a:ea typeface="Calibri" pitchFamily="34" charset="-122"/>
-                <a:cs typeface="Calibri" pitchFamily="34" charset="-120"/>
-              </a:rPr>
-              <a:t>Errors</a:t>
-            </a:r>
-            <a:endParaRPr lang="en-US" sz="1100" dirty="0"/>
-          </a:p>
-          <a:p>
-            <a:pPr marL="0" indent="0" algn="ctr">
-              <a:buNone/>
-            </a:pPr>
-            <a:r>
-              <a:rPr lang="en-US" sz="1100" b="1" dirty="0">
-                <a:solidFill>
-                  <a:srgbClr val="12262B"/>
-                </a:solidFill>
-                <a:latin typeface="Calibri" pitchFamily="34" charset="0"/>
-                <a:ea typeface="Calibri" pitchFamily="34" charset="-122"/>
-                <a:cs typeface="Calibri" pitchFamily="34" charset="-120"/>
-              </a:rPr>
-              <a:t>identified</a:t>
-            </a:r>
-            <a:endParaRPr lang="en-US" sz="1100" dirty="0"/>
-          </a:p>
-        </p:txBody>
-      </p:sp>
-      <p:sp>
-        <p:nvSpPr>
-          <p:cNvPr id="17" name="Shape 14"/>
-          <p:cNvSpPr/>
-          <p:nvPr/>
-        </p:nvSpPr>
-        <p:spPr>
-          <a:xfrm>
-            <a:off x="11192256" y="3968496"/>
-            <a:ext cx="292608" cy="292608"/>
-          </a:xfrm>
-          <a:prstGeom prst="ellipse">
-            <a:avLst/>
-          </a:prstGeom>
-          <a:solidFill>
-            <a:srgbClr val="A8403A"/>
-          </a:solidFill>
-          <a:ln/>
-        </p:spPr>
-      </p:sp>
-      <p:sp>
-        <p:nvSpPr>
-          <p:cNvPr id="18" name="Text 15"/>
-          <p:cNvSpPr/>
-          <p:nvPr/>
-        </p:nvSpPr>
-        <p:spPr>
-          <a:xfrm>
-            <a:off x="10424160" y="2971800"/>
-            <a:ext cx="1828800" cy="822960"/>
-          </a:xfrm>
-          <a:prstGeom prst="rect">
-            <a:avLst/>
-          </a:prstGeom>
-          <a:noFill/>
-          <a:ln/>
-        </p:spPr>
-        <p:txBody>
-          <a:bodyPr wrap="square" lIns="0" tIns="0" rIns="0" bIns="0" rtlCol="0" anchor="b"/>
-          <a:lstStyle/>
-          <a:p>
-            <a:pPr marL="0" indent="0" algn="ctr">
-              <a:buNone/>
-            </a:pPr>
-            <a:r>
-              <a:rPr lang="en-US" sz="1100" b="1" dirty="0">
-                <a:solidFill>
-                  <a:srgbClr val="12262B"/>
-                </a:solidFill>
-                <a:latin typeface="Calibri" pitchFamily="34" charset="0"/>
-                <a:ea typeface="Calibri" pitchFamily="34" charset="-122"/>
-                <a:cs typeface="Calibri" pitchFamily="34" charset="-120"/>
-              </a:rPr>
-              <a:t>Trials halted</a:t>
-            </a:r>
-            <a:endParaRPr lang="en-US" sz="1100" dirty="0"/>
-          </a:p>
-          <a:p>
-            <a:pPr marL="0" indent="0" algn="ctr">
-              <a:buNone/>
-            </a:pPr>
-            <a:r>
-              <a:rPr lang="en-US" sz="1100" b="1" dirty="0">
-                <a:solidFill>
-                  <a:srgbClr val="12262B"/>
-                </a:solidFill>
-                <a:latin typeface="Calibri" pitchFamily="34" charset="0"/>
-                <a:ea typeface="Calibri" pitchFamily="34" charset="-122"/>
-                <a:cs typeface="Calibri" pitchFamily="34" charset="-120"/>
-              </a:rPr>
-              <a:t>&amp; retractions</a:t>
-            </a:r>
-            <a:endParaRPr lang="en-US" sz="1100" dirty="0"/>
-          </a:p>
-        </p:txBody>
-      </p:sp>
-      <p:sp>
-        <p:nvSpPr>
-          <p:cNvPr id="19" name="Text 16"/>
-          <p:cNvSpPr/>
-          <p:nvPr/>
-        </p:nvSpPr>
-        <p:spPr>
-          <a:xfrm>
-            <a:off x="822960" y="5943600"/>
-            <a:ext cx="10515600" cy="274320"/>
-          </a:xfrm>
-          <a:prstGeom prst="rect">
-            <a:avLst/>
-          </a:prstGeom>
-          <a:noFill/>
-          <a:ln/>
-        </p:spPr>
-        <p:txBody>
-          <a:bodyPr wrap="square" lIns="0" tIns="0" rIns="0" bIns="0" rtlCol="0" anchor="ctr"/>
-          <a:lstStyle/>
-          <a:p>
-            <a:pPr marL="0" indent="0" algn="ctr">
-              <a:buNone/>
-            </a:pPr>
-            <a:r>
-              <a:rPr lang="en-US" sz="1000" i="1" dirty="0">
-                <a:solidFill>
-                  <a:srgbClr val="5B6B70"/>
-                </a:solidFill>
-                <a:latin typeface="Calibri" pitchFamily="34" charset="0"/>
-                <a:ea typeface="Calibri" pitchFamily="34" charset="-122"/>
-                <a:cs typeface="Calibri" pitchFamily="34" charset="-120"/>
-              </a:rPr>
-              <a:t>Verify exact dates against the published retraction record before use.</a:t>
-            </a:r>
-            <a:endParaRPr lang="en-US" sz="1000" dirty="0"/>
-          </a:p>
-        </p:txBody>
-      </p:sp>
-    </p:spTree>
-  </p:cSld>
-  <p:clrMapOvr>
-    <a:masterClrMapping/>
-  </p:clrMapOvr>
-</p:sld>
-</file>
-
-<file path=ppt/slides/slide19.xml><?xml version="1.0" encoding="utf-8"?>
 <p:sld xmlns:a="http://schemas.openxmlformats.org/drawingml/2006/main" xmlns:r="http://schemas.openxmlformats.org/officeDocument/2006/relationships" xmlns:p="http://schemas.openxmlformats.org/presentationml/2006/main">
   <p:cSld name="Slide 19">
     <p:bg>
@@ -16268,6 +15760,52 @@
               </a:rPr>
               <a:t>Selective reporting of the best-looking result.</a:t>
             </a:r>
+          </a:p>
+          <a:p>
+            <a:pPr marL="203200" indent="-203200">
+              <a:spcAft>
+                <a:spcPts val="1300"/>
+              </a:spcAft>
+              <a:buSzPct val="100000"/>
+              <a:buChar char="•"/>
+            </a:pPr>
+            <a:endParaRPr lang="en-US" sz="1600" dirty="0">
+              <a:solidFill>
+                <a:srgbClr val="12262B"/>
+              </a:solidFill>
+              <a:latin typeface="Calibri" pitchFamily="34" charset="0"/>
+              <a:cs typeface="Calibri" pitchFamily="34" charset="-120"/>
+            </a:endParaRPr>
+          </a:p>
+          <a:p>
+            <a:pPr marL="203200" indent="-203200">
+              <a:spcAft>
+                <a:spcPts val="1300"/>
+              </a:spcAft>
+              <a:buSzPct val="100000"/>
+              <a:buFontTx/>
+              <a:buChar char="•"/>
+            </a:pPr>
+            <a:r>
+              <a:rPr lang="en-US" sz="1600" b="1" dirty="0">
+                <a:solidFill>
+                  <a:srgbClr val="0E7C86"/>
+                </a:solidFill>
+                <a:latin typeface="Calibri" pitchFamily="34" charset="0"/>
+                <a:ea typeface="Calibri" pitchFamily="34" charset="-122"/>
+                <a:cs typeface="Calibri" pitchFamily="34" charset="-120"/>
+              </a:rPr>
+              <a:t>We aim to have a model that might reach only 0.8 but it holds in the validation</a:t>
+            </a:r>
+          </a:p>
+          <a:p>
+            <a:pPr marL="203200" indent="-203200">
+              <a:spcAft>
+                <a:spcPts val="1300"/>
+              </a:spcAft>
+              <a:buSzPct val="100000"/>
+              <a:buChar char="•"/>
+            </a:pPr>
             <a:endParaRPr lang="en-US" sz="1600" dirty="0"/>
           </a:p>
         </p:txBody>
@@ -16324,6 +15862,543 @@
               <a:t>≈ chance line near 0.5</a:t>
             </a:r>
             <a:endParaRPr lang="en-US" sz="1000" dirty="0"/>
+          </a:p>
+        </p:txBody>
+      </p:sp>
+    </p:spTree>
+  </p:cSld>
+  <p:clrMapOvr>
+    <a:masterClrMapping/>
+  </p:clrMapOvr>
+</p:sld>
+</file>
+
+<file path=ppt/slides/slide19.xml><?xml version="1.0" encoding="utf-8"?>
+<p:sld xmlns:a="http://schemas.openxmlformats.org/drawingml/2006/main" xmlns:r="http://schemas.openxmlformats.org/officeDocument/2006/relationships" xmlns:p="http://schemas.openxmlformats.org/presentationml/2006/main">
+  <p:cSld name="Slide 20">
+    <p:bg>
+      <p:bgPr>
+        <a:solidFill>
+          <a:srgbClr val="FFFFFF"/>
+        </a:solidFill>
+        <a:effectLst/>
+      </p:bgPr>
+    </p:bg>
+    <p:spTree>
+      <p:nvGrpSpPr>
+        <p:cNvPr id="1" name=""/>
+        <p:cNvGrpSpPr/>
+        <p:nvPr/>
+      </p:nvGrpSpPr>
+      <p:grpSpPr>
+        <a:xfrm>
+          <a:off x="0" y="0"/>
+          <a:ext cx="0" cy="0"/>
+          <a:chOff x="0" y="0"/>
+          <a:chExt cx="0" cy="0"/>
+        </a:xfrm>
+      </p:grpSpPr>
+      <p:sp>
+        <p:nvSpPr>
+          <p:cNvPr id="2" name="Text 0"/>
+          <p:cNvSpPr/>
+          <p:nvPr/>
+        </p:nvSpPr>
+        <p:spPr>
+          <a:xfrm>
+            <a:off x="548640" y="384048"/>
+            <a:ext cx="10515600" cy="274320"/>
+          </a:xfrm>
+          <a:prstGeom prst="rect">
+            <a:avLst/>
+          </a:prstGeom>
+          <a:noFill/>
+          <a:ln/>
+        </p:spPr>
+        <p:txBody>
+          <a:bodyPr wrap="square" lIns="0" tIns="0" rIns="0" bIns="0" rtlCol="0" anchor="ctr"/>
+          <a:lstStyle/>
+          <a:p>
+            <a:pPr marL="0" indent="0">
+              <a:buNone/>
+            </a:pPr>
+            <a:r>
+              <a:rPr lang="en-US" sz="1200" b="1" kern="0" spc="200" dirty="0">
+                <a:solidFill>
+                  <a:srgbClr val="0E7C86"/>
+                </a:solidFill>
+                <a:latin typeface="Calibri" pitchFamily="34" charset="0"/>
+                <a:ea typeface="Calibri" pitchFamily="34" charset="-122"/>
+                <a:cs typeface="Calibri" pitchFamily="34" charset="-120"/>
+              </a:rPr>
+              <a:t>WHAT SUCCESS LOOKS LIKE</a:t>
+            </a:r>
+            <a:endParaRPr lang="en-US" sz="1200" dirty="0"/>
+          </a:p>
+        </p:txBody>
+      </p:sp>
+      <p:sp>
+        <p:nvSpPr>
+          <p:cNvPr id="3" name="Text 1"/>
+          <p:cNvSpPr/>
+          <p:nvPr/>
+        </p:nvSpPr>
+        <p:spPr>
+          <a:xfrm>
+            <a:off x="548640" y="658368"/>
+            <a:ext cx="11064240" cy="868680"/>
+          </a:xfrm>
+          <a:prstGeom prst="rect">
+            <a:avLst/>
+          </a:prstGeom>
+          <a:noFill/>
+          <a:ln/>
+        </p:spPr>
+        <p:txBody>
+          <a:bodyPr wrap="square" lIns="0" tIns="0" rIns="0" bIns="0" rtlCol="0" anchor="t"/>
+          <a:lstStyle/>
+          <a:p>
+            <a:pPr marL="0" indent="0">
+              <a:buNone/>
+            </a:pPr>
+            <a:r>
+              <a:rPr lang="en-US" sz="3000" b="1" dirty="0">
+                <a:solidFill>
+                  <a:srgbClr val="12262B"/>
+                </a:solidFill>
+                <a:latin typeface="Cambria" pitchFamily="34" charset="0"/>
+                <a:ea typeface="Cambria" pitchFamily="34" charset="-122"/>
+                <a:cs typeface="Cambria" pitchFamily="34" charset="-120"/>
+              </a:rPr>
+              <a:t>Biomarkers that held up share three traits</a:t>
+            </a:r>
+            <a:endParaRPr lang="en-US" sz="3000" dirty="0"/>
+          </a:p>
+        </p:txBody>
+      </p:sp>
+      <p:sp>
+        <p:nvSpPr>
+          <p:cNvPr id="4" name="Text 2"/>
+          <p:cNvSpPr/>
+          <p:nvPr/>
+        </p:nvSpPr>
+        <p:spPr>
+          <a:xfrm>
+            <a:off x="548640" y="6473952"/>
+            <a:ext cx="7315200" cy="274320"/>
+          </a:xfrm>
+          <a:prstGeom prst="rect">
+            <a:avLst/>
+          </a:prstGeom>
+          <a:noFill/>
+          <a:ln/>
+        </p:spPr>
+        <p:txBody>
+          <a:bodyPr wrap="square" lIns="0" tIns="0" rIns="0" bIns="0" rtlCol="0" anchor="ctr"/>
+          <a:lstStyle/>
+          <a:p>
+            <a:pPr marL="0" indent="0">
+              <a:buNone/>
+            </a:pPr>
+            <a:r>
+              <a:rPr lang="en-US" sz="900" dirty="0">
+                <a:solidFill>
+                  <a:srgbClr val="5B6B70"/>
+                </a:solidFill>
+                <a:latin typeface="Calibri" pitchFamily="34" charset="0"/>
+                <a:ea typeface="Calibri" pitchFamily="34" charset="-122"/>
+                <a:cs typeface="Calibri" pitchFamily="34" charset="-120"/>
+              </a:rPr>
+              <a:t>Practical ML for Transcriptomics  ·  Lecture 1</a:t>
+            </a:r>
+            <a:endParaRPr lang="en-US" sz="900" dirty="0"/>
+          </a:p>
+        </p:txBody>
+      </p:sp>
+      <p:sp>
+        <p:nvSpPr>
+          <p:cNvPr id="5" name="Text 3"/>
+          <p:cNvSpPr/>
+          <p:nvPr/>
+        </p:nvSpPr>
+        <p:spPr>
+          <a:xfrm>
+            <a:off x="11247120" y="6473952"/>
+            <a:ext cx="365760" cy="274320"/>
+          </a:xfrm>
+          <a:prstGeom prst="rect">
+            <a:avLst/>
+          </a:prstGeom>
+          <a:noFill/>
+          <a:ln/>
+        </p:spPr>
+        <p:txBody>
+          <a:bodyPr wrap="square" lIns="0" tIns="0" rIns="0" bIns="0" rtlCol="0" anchor="ctr"/>
+          <a:lstStyle/>
+          <a:p>
+            <a:pPr marL="0" indent="0" algn="r">
+              <a:buNone/>
+            </a:pPr>
+            <a:r>
+              <a:rPr lang="en-US" sz="900" dirty="0">
+                <a:solidFill>
+                  <a:srgbClr val="5B6B70"/>
+                </a:solidFill>
+                <a:latin typeface="Calibri" pitchFamily="34" charset="0"/>
+                <a:ea typeface="Calibri" pitchFamily="34" charset="-122"/>
+                <a:cs typeface="Calibri" pitchFamily="34" charset="-120"/>
+              </a:rPr>
+              <a:t>20</a:t>
+            </a:r>
+            <a:endParaRPr lang="en-US" sz="900" dirty="0"/>
+          </a:p>
+        </p:txBody>
+      </p:sp>
+      <p:sp>
+        <p:nvSpPr>
+          <p:cNvPr id="7" name="Shape 4"/>
+          <p:cNvSpPr/>
+          <p:nvPr/>
+        </p:nvSpPr>
+        <p:spPr>
+          <a:xfrm>
+            <a:off x="548640" y="1828800"/>
+            <a:ext cx="5486400" cy="4023360"/>
+          </a:xfrm>
+          <a:prstGeom prst="roundRect">
+            <a:avLst>
+              <a:gd name="adj" fmla="val 1818"/>
+            </a:avLst>
+          </a:prstGeom>
+          <a:solidFill>
+            <a:srgbClr val="F2DEDB"/>
+          </a:solidFill>
+          <a:ln/>
+          <a:effectLst>
+            <a:outerShdw blurRad="88900" dist="38100" dir="5400000" algn="bl" rotWithShape="0">
+              <a:srgbClr val="000000">
+                <a:alpha val="12000"/>
+              </a:srgbClr>
+            </a:outerShdw>
+          </a:effectLst>
+        </p:spPr>
+      </p:sp>
+      <p:sp>
+        <p:nvSpPr>
+          <p:cNvPr id="8" name="Text 5"/>
+          <p:cNvSpPr/>
+          <p:nvPr/>
+        </p:nvSpPr>
+        <p:spPr>
+          <a:xfrm>
+            <a:off x="914400" y="2057400"/>
+            <a:ext cx="4754880" cy="457200"/>
+          </a:xfrm>
+          <a:prstGeom prst="rect">
+            <a:avLst/>
+          </a:prstGeom>
+          <a:noFill/>
+          <a:ln/>
+        </p:spPr>
+        <p:txBody>
+          <a:bodyPr wrap="square" lIns="0" tIns="0" rIns="0" bIns="0" rtlCol="0" anchor="ctr"/>
+          <a:lstStyle/>
+          <a:p>
+            <a:pPr marL="0" indent="0">
+              <a:buNone/>
+            </a:pPr>
+            <a:r>
+              <a:rPr lang="en-US" sz="2000" b="1" dirty="0">
+                <a:solidFill>
+                  <a:srgbClr val="A8403A"/>
+                </a:solidFill>
+                <a:latin typeface="Cambria" pitchFamily="34" charset="0"/>
+                <a:ea typeface="Cambria" pitchFamily="34" charset="-122"/>
+                <a:cs typeface="Cambria" pitchFamily="34" charset="-120"/>
+              </a:rPr>
+              <a:t>Failed</a:t>
+            </a:r>
+            <a:endParaRPr lang="en-US" sz="2000" dirty="0"/>
+          </a:p>
+        </p:txBody>
+      </p:sp>
+      <p:sp>
+        <p:nvSpPr>
+          <p:cNvPr id="9" name="Text 6"/>
+          <p:cNvSpPr/>
+          <p:nvPr/>
+        </p:nvSpPr>
+        <p:spPr>
+          <a:xfrm>
+            <a:off x="914400" y="2697480"/>
+            <a:ext cx="4754880" cy="2926080"/>
+          </a:xfrm>
+          <a:prstGeom prst="rect">
+            <a:avLst/>
+          </a:prstGeom>
+          <a:noFill/>
+          <a:ln/>
+        </p:spPr>
+        <p:txBody>
+          <a:bodyPr wrap="square" lIns="0" tIns="0" rIns="0" bIns="0" rtlCol="0" anchor="t"/>
+          <a:lstStyle/>
+          <a:p>
+            <a:pPr marL="203200" indent="-203200">
+              <a:spcAft>
+                <a:spcPts val="1400"/>
+              </a:spcAft>
+              <a:buSzPct val="100000"/>
+              <a:buChar char="•"/>
+            </a:pPr>
+            <a:r>
+              <a:rPr lang="en-US" sz="1450" dirty="0">
+                <a:solidFill>
+                  <a:srgbClr val="12262B"/>
+                </a:solidFill>
+                <a:latin typeface="Calibri" pitchFamily="34" charset="0"/>
+                <a:ea typeface="Calibri" pitchFamily="34" charset="-122"/>
+                <a:cs typeface="Calibri" pitchFamily="34" charset="-120"/>
+              </a:rPr>
+              <a:t>Single cohort, no independent validation</a:t>
+            </a:r>
+            <a:endParaRPr lang="en-US" sz="1450" dirty="0"/>
+          </a:p>
+          <a:p>
+            <a:pPr marL="203200" indent="-203200">
+              <a:spcAft>
+                <a:spcPts val="1400"/>
+              </a:spcAft>
+              <a:buSzPct val="100000"/>
+              <a:buChar char="•"/>
+            </a:pPr>
+            <a:r>
+              <a:rPr lang="en-US" sz="1450" dirty="0">
+                <a:solidFill>
+                  <a:srgbClr val="12262B"/>
+                </a:solidFill>
+                <a:latin typeface="Calibri" pitchFamily="34" charset="0"/>
+                <a:ea typeface="Calibri" pitchFamily="34" charset="-122"/>
+                <a:cs typeface="Calibri" pitchFamily="34" charset="-120"/>
+              </a:rPr>
+              <a:t>Post-hoc signature, chosen after seeing data</a:t>
+            </a:r>
+            <a:endParaRPr lang="en-US" sz="1450" dirty="0"/>
+          </a:p>
+          <a:p>
+            <a:pPr marL="203200" indent="-203200">
+              <a:spcAft>
+                <a:spcPts val="1400"/>
+              </a:spcAft>
+              <a:buSzPct val="100000"/>
+              <a:buChar char="•"/>
+            </a:pPr>
+            <a:r>
+              <a:rPr lang="en-US" sz="1450" dirty="0">
+                <a:solidFill>
+                  <a:srgbClr val="12262B"/>
+                </a:solidFill>
+                <a:latin typeface="Calibri" pitchFamily="34" charset="0"/>
+                <a:ea typeface="Calibri" pitchFamily="34" charset="-122"/>
+                <a:cs typeface="Calibri" pitchFamily="34" charset="-120"/>
+              </a:rPr>
+              <a:t>Leakage in feature selection / normalisation</a:t>
+            </a:r>
+            <a:endParaRPr lang="en-US" sz="1450" dirty="0"/>
+          </a:p>
+          <a:p>
+            <a:pPr marL="203200" indent="-203200">
+              <a:spcAft>
+                <a:spcPts val="1400"/>
+              </a:spcAft>
+              <a:buSzPct val="100000"/>
+              <a:buChar char="•"/>
+            </a:pPr>
+            <a:r>
+              <a:rPr lang="en-US" sz="1450" dirty="0">
+                <a:solidFill>
+                  <a:srgbClr val="12262B"/>
+                </a:solidFill>
+                <a:latin typeface="Calibri" pitchFamily="34" charset="0"/>
+                <a:ea typeface="Calibri" pitchFamily="34" charset="-122"/>
+                <a:cs typeface="Calibri" pitchFamily="34" charset="-120"/>
+              </a:rPr>
+              <a:t>Statistical association only</a:t>
+            </a:r>
+            <a:endParaRPr lang="en-US" sz="1450" dirty="0"/>
+          </a:p>
+        </p:txBody>
+      </p:sp>
+      <p:sp>
+        <p:nvSpPr>
+          <p:cNvPr id="10" name="Shape 7"/>
+          <p:cNvSpPr/>
+          <p:nvPr/>
+        </p:nvSpPr>
+        <p:spPr>
+          <a:xfrm>
+            <a:off x="6309360" y="1828800"/>
+            <a:ext cx="5486400" cy="4023360"/>
+          </a:xfrm>
+          <a:prstGeom prst="roundRect">
+            <a:avLst>
+              <a:gd name="adj" fmla="val 1818"/>
+            </a:avLst>
+          </a:prstGeom>
+          <a:solidFill>
+            <a:srgbClr val="DCEEE4"/>
+          </a:solidFill>
+          <a:ln/>
+          <a:effectLst>
+            <a:outerShdw blurRad="88900" dist="38100" dir="5400000" algn="bl" rotWithShape="0">
+              <a:srgbClr val="000000">
+                <a:alpha val="12000"/>
+              </a:srgbClr>
+            </a:outerShdw>
+          </a:effectLst>
+        </p:spPr>
+      </p:sp>
+      <p:sp>
+        <p:nvSpPr>
+          <p:cNvPr id="11" name="Text 8"/>
+          <p:cNvSpPr/>
+          <p:nvPr/>
+        </p:nvSpPr>
+        <p:spPr>
+          <a:xfrm>
+            <a:off x="6675120" y="2057400"/>
+            <a:ext cx="4754880" cy="457200"/>
+          </a:xfrm>
+          <a:prstGeom prst="rect">
+            <a:avLst/>
+          </a:prstGeom>
+          <a:noFill/>
+          <a:ln/>
+        </p:spPr>
+        <p:txBody>
+          <a:bodyPr wrap="square" lIns="0" tIns="0" rIns="0" bIns="0" rtlCol="0" anchor="ctr"/>
+          <a:lstStyle/>
+          <a:p>
+            <a:pPr marL="0" indent="0">
+              <a:buNone/>
+            </a:pPr>
+            <a:r>
+              <a:rPr lang="en-US" sz="2000" b="1" dirty="0">
+                <a:solidFill>
+                  <a:srgbClr val="2E7D57"/>
+                </a:solidFill>
+                <a:latin typeface="Cambria" pitchFamily="34" charset="0"/>
+                <a:ea typeface="Cambria" pitchFamily="34" charset="-122"/>
+                <a:cs typeface="Cambria" pitchFamily="34" charset="-120"/>
+              </a:rPr>
+              <a:t>Validated</a:t>
+            </a:r>
+            <a:endParaRPr lang="en-US" sz="2000" dirty="0"/>
+          </a:p>
+        </p:txBody>
+      </p:sp>
+      <p:sp>
+        <p:nvSpPr>
+          <p:cNvPr id="12" name="Text 9"/>
+          <p:cNvSpPr/>
+          <p:nvPr/>
+        </p:nvSpPr>
+        <p:spPr>
+          <a:xfrm>
+            <a:off x="6675120" y="2697480"/>
+            <a:ext cx="4754880" cy="2926080"/>
+          </a:xfrm>
+          <a:prstGeom prst="rect">
+            <a:avLst/>
+          </a:prstGeom>
+          <a:noFill/>
+          <a:ln/>
+        </p:spPr>
+        <p:txBody>
+          <a:bodyPr wrap="square" lIns="0" tIns="0" rIns="0" bIns="0" rtlCol="0" anchor="t"/>
+          <a:lstStyle/>
+          <a:p>
+            <a:pPr marL="203200" indent="-203200">
+              <a:spcAft>
+                <a:spcPts val="1400"/>
+              </a:spcAft>
+              <a:buSzPct val="100000"/>
+              <a:buChar char="•"/>
+            </a:pPr>
+            <a:r>
+              <a:rPr lang="en-US" sz="1450" dirty="0">
+                <a:solidFill>
+                  <a:srgbClr val="12262B"/>
+                </a:solidFill>
+                <a:latin typeface="Calibri" pitchFamily="34" charset="0"/>
+                <a:ea typeface="Calibri" pitchFamily="34" charset="-122"/>
+                <a:cs typeface="Calibri" pitchFamily="34" charset="-120"/>
+              </a:rPr>
+              <a:t>Pre-specified, locked-down signature</a:t>
+            </a:r>
+            <a:endParaRPr lang="en-US" sz="1450" dirty="0"/>
+          </a:p>
+          <a:p>
+            <a:pPr marL="203200" indent="-203200">
+              <a:spcAft>
+                <a:spcPts val="1400"/>
+              </a:spcAft>
+              <a:buSzPct val="100000"/>
+              <a:buChar char="•"/>
+            </a:pPr>
+            <a:r>
+              <a:rPr lang="en-US" sz="1450" dirty="0">
+                <a:solidFill>
+                  <a:srgbClr val="12262B"/>
+                </a:solidFill>
+                <a:latin typeface="Calibri" pitchFamily="34" charset="0"/>
+                <a:ea typeface="Calibri" pitchFamily="34" charset="-122"/>
+                <a:cs typeface="Calibri" pitchFamily="34" charset="-120"/>
+              </a:rPr>
+              <a:t>Independent multi-cohort validation</a:t>
+            </a:r>
+            <a:endParaRPr lang="en-US" sz="1450" dirty="0"/>
+          </a:p>
+          <a:p>
+            <a:pPr marL="203200" indent="-203200">
+              <a:spcAft>
+                <a:spcPts val="1400"/>
+              </a:spcAft>
+              <a:buSzPct val="100000"/>
+              <a:buChar char="•"/>
+            </a:pPr>
+            <a:r>
+              <a:rPr lang="en-US" sz="1450" dirty="0">
+                <a:solidFill>
+                  <a:srgbClr val="12262B"/>
+                </a:solidFill>
+                <a:latin typeface="Calibri" pitchFamily="34" charset="0"/>
+                <a:ea typeface="Calibri" pitchFamily="34" charset="-122"/>
+                <a:cs typeface="Calibri" pitchFamily="34" charset="-120"/>
+              </a:rPr>
+              <a:t>Demonstrated clinical utility (change decision), not just association</a:t>
+            </a:r>
+            <a:endParaRPr lang="en-US" sz="1450" dirty="0"/>
+          </a:p>
+          <a:p>
+            <a:pPr marL="203200" indent="-203200">
+              <a:spcAft>
+                <a:spcPts val="1400"/>
+              </a:spcAft>
+              <a:buSzPct val="100000"/>
+              <a:buChar char="•"/>
+            </a:pPr>
+            <a:r>
+              <a:rPr lang="en-US" sz="1450" dirty="0">
+                <a:solidFill>
+                  <a:srgbClr val="12262B"/>
+                </a:solidFill>
+                <a:latin typeface="Calibri" pitchFamily="34" charset="0"/>
+                <a:ea typeface="Calibri" pitchFamily="34" charset="-122"/>
+                <a:cs typeface="Calibri" pitchFamily="34" charset="-120"/>
+              </a:rPr>
+              <a:t>Reproducible, documented pipeline</a:t>
+            </a:r>
+            <a:endParaRPr lang="en-US" sz="1450" dirty="0"/>
           </a:p>
         </p:txBody>
       </p:sp>
@@ -17354,543 +17429,6 @@
 
 <file path=ppt/slides/slide20.xml><?xml version="1.0" encoding="utf-8"?>
 <p:sld xmlns:a="http://schemas.openxmlformats.org/drawingml/2006/main" xmlns:r="http://schemas.openxmlformats.org/officeDocument/2006/relationships" xmlns:p="http://schemas.openxmlformats.org/presentationml/2006/main">
-  <p:cSld name="Slide 20">
-    <p:bg>
-      <p:bgPr>
-        <a:solidFill>
-          <a:srgbClr val="FFFFFF"/>
-        </a:solidFill>
-        <a:effectLst/>
-      </p:bgPr>
-    </p:bg>
-    <p:spTree>
-      <p:nvGrpSpPr>
-        <p:cNvPr id="1" name=""/>
-        <p:cNvGrpSpPr/>
-        <p:nvPr/>
-      </p:nvGrpSpPr>
-      <p:grpSpPr>
-        <a:xfrm>
-          <a:off x="0" y="0"/>
-          <a:ext cx="0" cy="0"/>
-          <a:chOff x="0" y="0"/>
-          <a:chExt cx="0" cy="0"/>
-        </a:xfrm>
-      </p:grpSpPr>
-      <p:sp>
-        <p:nvSpPr>
-          <p:cNvPr id="2" name="Text 0"/>
-          <p:cNvSpPr/>
-          <p:nvPr/>
-        </p:nvSpPr>
-        <p:spPr>
-          <a:xfrm>
-            <a:off x="548640" y="384048"/>
-            <a:ext cx="10515600" cy="274320"/>
-          </a:xfrm>
-          <a:prstGeom prst="rect">
-            <a:avLst/>
-          </a:prstGeom>
-          <a:noFill/>
-          <a:ln/>
-        </p:spPr>
-        <p:txBody>
-          <a:bodyPr wrap="square" lIns="0" tIns="0" rIns="0" bIns="0" rtlCol="0" anchor="ctr"/>
-          <a:lstStyle/>
-          <a:p>
-            <a:pPr marL="0" indent="0">
-              <a:buNone/>
-            </a:pPr>
-            <a:r>
-              <a:rPr lang="en-US" sz="1200" b="1" kern="0" spc="200" dirty="0">
-                <a:solidFill>
-                  <a:srgbClr val="0E7C86"/>
-                </a:solidFill>
-                <a:latin typeface="Calibri" pitchFamily="34" charset="0"/>
-                <a:ea typeface="Calibri" pitchFamily="34" charset="-122"/>
-                <a:cs typeface="Calibri" pitchFamily="34" charset="-120"/>
-              </a:rPr>
-              <a:t>WHAT SUCCESS LOOKS LIKE</a:t>
-            </a:r>
-            <a:endParaRPr lang="en-US" sz="1200" dirty="0"/>
-          </a:p>
-        </p:txBody>
-      </p:sp>
-      <p:sp>
-        <p:nvSpPr>
-          <p:cNvPr id="3" name="Text 1"/>
-          <p:cNvSpPr/>
-          <p:nvPr/>
-        </p:nvSpPr>
-        <p:spPr>
-          <a:xfrm>
-            <a:off x="548640" y="658368"/>
-            <a:ext cx="11064240" cy="868680"/>
-          </a:xfrm>
-          <a:prstGeom prst="rect">
-            <a:avLst/>
-          </a:prstGeom>
-          <a:noFill/>
-          <a:ln/>
-        </p:spPr>
-        <p:txBody>
-          <a:bodyPr wrap="square" lIns="0" tIns="0" rIns="0" bIns="0" rtlCol="0" anchor="t"/>
-          <a:lstStyle/>
-          <a:p>
-            <a:pPr marL="0" indent="0">
-              <a:buNone/>
-            </a:pPr>
-            <a:r>
-              <a:rPr lang="en-US" sz="3000" b="1" dirty="0">
-                <a:solidFill>
-                  <a:srgbClr val="12262B"/>
-                </a:solidFill>
-                <a:latin typeface="Cambria" pitchFamily="34" charset="0"/>
-                <a:ea typeface="Cambria" pitchFamily="34" charset="-122"/>
-                <a:cs typeface="Cambria" pitchFamily="34" charset="-120"/>
-              </a:rPr>
-              <a:t>Biomarkers that held up share three traits</a:t>
-            </a:r>
-            <a:endParaRPr lang="en-US" sz="3000" dirty="0"/>
-          </a:p>
-        </p:txBody>
-      </p:sp>
-      <p:sp>
-        <p:nvSpPr>
-          <p:cNvPr id="4" name="Text 2"/>
-          <p:cNvSpPr/>
-          <p:nvPr/>
-        </p:nvSpPr>
-        <p:spPr>
-          <a:xfrm>
-            <a:off x="548640" y="6473952"/>
-            <a:ext cx="7315200" cy="274320"/>
-          </a:xfrm>
-          <a:prstGeom prst="rect">
-            <a:avLst/>
-          </a:prstGeom>
-          <a:noFill/>
-          <a:ln/>
-        </p:spPr>
-        <p:txBody>
-          <a:bodyPr wrap="square" lIns="0" tIns="0" rIns="0" bIns="0" rtlCol="0" anchor="ctr"/>
-          <a:lstStyle/>
-          <a:p>
-            <a:pPr marL="0" indent="0">
-              <a:buNone/>
-            </a:pPr>
-            <a:r>
-              <a:rPr lang="en-US" sz="900" dirty="0">
-                <a:solidFill>
-                  <a:srgbClr val="5B6B70"/>
-                </a:solidFill>
-                <a:latin typeface="Calibri" pitchFamily="34" charset="0"/>
-                <a:ea typeface="Calibri" pitchFamily="34" charset="-122"/>
-                <a:cs typeface="Calibri" pitchFamily="34" charset="-120"/>
-              </a:rPr>
-              <a:t>Practical ML for Transcriptomics  ·  Lecture 1</a:t>
-            </a:r>
-            <a:endParaRPr lang="en-US" sz="900" dirty="0"/>
-          </a:p>
-        </p:txBody>
-      </p:sp>
-      <p:sp>
-        <p:nvSpPr>
-          <p:cNvPr id="5" name="Text 3"/>
-          <p:cNvSpPr/>
-          <p:nvPr/>
-        </p:nvSpPr>
-        <p:spPr>
-          <a:xfrm>
-            <a:off x="11247120" y="6473952"/>
-            <a:ext cx="365760" cy="274320"/>
-          </a:xfrm>
-          <a:prstGeom prst="rect">
-            <a:avLst/>
-          </a:prstGeom>
-          <a:noFill/>
-          <a:ln/>
-        </p:spPr>
-        <p:txBody>
-          <a:bodyPr wrap="square" lIns="0" tIns="0" rIns="0" bIns="0" rtlCol="0" anchor="ctr"/>
-          <a:lstStyle/>
-          <a:p>
-            <a:pPr marL="0" indent="0" algn="r">
-              <a:buNone/>
-            </a:pPr>
-            <a:r>
-              <a:rPr lang="en-US" sz="900" dirty="0">
-                <a:solidFill>
-                  <a:srgbClr val="5B6B70"/>
-                </a:solidFill>
-                <a:latin typeface="Calibri" pitchFamily="34" charset="0"/>
-                <a:ea typeface="Calibri" pitchFamily="34" charset="-122"/>
-                <a:cs typeface="Calibri" pitchFamily="34" charset="-120"/>
-              </a:rPr>
-              <a:t>20</a:t>
-            </a:r>
-            <a:endParaRPr lang="en-US" sz="900" dirty="0"/>
-          </a:p>
-        </p:txBody>
-      </p:sp>
-      <p:sp>
-        <p:nvSpPr>
-          <p:cNvPr id="7" name="Shape 4"/>
-          <p:cNvSpPr/>
-          <p:nvPr/>
-        </p:nvSpPr>
-        <p:spPr>
-          <a:xfrm>
-            <a:off x="548640" y="1828800"/>
-            <a:ext cx="5486400" cy="4023360"/>
-          </a:xfrm>
-          <a:prstGeom prst="roundRect">
-            <a:avLst>
-              <a:gd name="adj" fmla="val 1818"/>
-            </a:avLst>
-          </a:prstGeom>
-          <a:solidFill>
-            <a:srgbClr val="F2DEDB"/>
-          </a:solidFill>
-          <a:ln/>
-          <a:effectLst>
-            <a:outerShdw blurRad="88900" dist="38100" dir="5400000" algn="bl" rotWithShape="0">
-              <a:srgbClr val="000000">
-                <a:alpha val="12000"/>
-              </a:srgbClr>
-            </a:outerShdw>
-          </a:effectLst>
-        </p:spPr>
-      </p:sp>
-      <p:sp>
-        <p:nvSpPr>
-          <p:cNvPr id="8" name="Text 5"/>
-          <p:cNvSpPr/>
-          <p:nvPr/>
-        </p:nvSpPr>
-        <p:spPr>
-          <a:xfrm>
-            <a:off x="914400" y="2057400"/>
-            <a:ext cx="4754880" cy="457200"/>
-          </a:xfrm>
-          <a:prstGeom prst="rect">
-            <a:avLst/>
-          </a:prstGeom>
-          <a:noFill/>
-          <a:ln/>
-        </p:spPr>
-        <p:txBody>
-          <a:bodyPr wrap="square" lIns="0" tIns="0" rIns="0" bIns="0" rtlCol="0" anchor="ctr"/>
-          <a:lstStyle/>
-          <a:p>
-            <a:pPr marL="0" indent="0">
-              <a:buNone/>
-            </a:pPr>
-            <a:r>
-              <a:rPr lang="en-US" sz="2000" b="1" dirty="0">
-                <a:solidFill>
-                  <a:srgbClr val="A8403A"/>
-                </a:solidFill>
-                <a:latin typeface="Cambria" pitchFamily="34" charset="0"/>
-                <a:ea typeface="Cambria" pitchFamily="34" charset="-122"/>
-                <a:cs typeface="Cambria" pitchFamily="34" charset="-120"/>
-              </a:rPr>
-              <a:t>Failed</a:t>
-            </a:r>
-            <a:endParaRPr lang="en-US" sz="2000" dirty="0"/>
-          </a:p>
-        </p:txBody>
-      </p:sp>
-      <p:sp>
-        <p:nvSpPr>
-          <p:cNvPr id="9" name="Text 6"/>
-          <p:cNvSpPr/>
-          <p:nvPr/>
-        </p:nvSpPr>
-        <p:spPr>
-          <a:xfrm>
-            <a:off x="914400" y="2697480"/>
-            <a:ext cx="4754880" cy="2926080"/>
-          </a:xfrm>
-          <a:prstGeom prst="rect">
-            <a:avLst/>
-          </a:prstGeom>
-          <a:noFill/>
-          <a:ln/>
-        </p:spPr>
-        <p:txBody>
-          <a:bodyPr wrap="square" lIns="0" tIns="0" rIns="0" bIns="0" rtlCol="0" anchor="t"/>
-          <a:lstStyle/>
-          <a:p>
-            <a:pPr marL="203200" indent="-203200">
-              <a:spcAft>
-                <a:spcPts val="1400"/>
-              </a:spcAft>
-              <a:buSzPct val="100000"/>
-              <a:buChar char="•"/>
-            </a:pPr>
-            <a:r>
-              <a:rPr lang="en-US" sz="1450" dirty="0">
-                <a:solidFill>
-                  <a:srgbClr val="12262B"/>
-                </a:solidFill>
-                <a:latin typeface="Calibri" pitchFamily="34" charset="0"/>
-                <a:ea typeface="Calibri" pitchFamily="34" charset="-122"/>
-                <a:cs typeface="Calibri" pitchFamily="34" charset="-120"/>
-              </a:rPr>
-              <a:t>Single cohort, no independent validation</a:t>
-            </a:r>
-            <a:endParaRPr lang="en-US" sz="1450" dirty="0"/>
-          </a:p>
-          <a:p>
-            <a:pPr marL="203200" indent="-203200">
-              <a:spcAft>
-                <a:spcPts val="1400"/>
-              </a:spcAft>
-              <a:buSzPct val="100000"/>
-              <a:buChar char="•"/>
-            </a:pPr>
-            <a:r>
-              <a:rPr lang="en-US" sz="1450" dirty="0">
-                <a:solidFill>
-                  <a:srgbClr val="12262B"/>
-                </a:solidFill>
-                <a:latin typeface="Calibri" pitchFamily="34" charset="0"/>
-                <a:ea typeface="Calibri" pitchFamily="34" charset="-122"/>
-                <a:cs typeface="Calibri" pitchFamily="34" charset="-120"/>
-              </a:rPr>
-              <a:t>Post-hoc signature, chosen after seeing data</a:t>
-            </a:r>
-            <a:endParaRPr lang="en-US" sz="1450" dirty="0"/>
-          </a:p>
-          <a:p>
-            <a:pPr marL="203200" indent="-203200">
-              <a:spcAft>
-                <a:spcPts val="1400"/>
-              </a:spcAft>
-              <a:buSzPct val="100000"/>
-              <a:buChar char="•"/>
-            </a:pPr>
-            <a:r>
-              <a:rPr lang="en-US" sz="1450" dirty="0">
-                <a:solidFill>
-                  <a:srgbClr val="12262B"/>
-                </a:solidFill>
-                <a:latin typeface="Calibri" pitchFamily="34" charset="0"/>
-                <a:ea typeface="Calibri" pitchFamily="34" charset="-122"/>
-                <a:cs typeface="Calibri" pitchFamily="34" charset="-120"/>
-              </a:rPr>
-              <a:t>Leakage in feature selection / normalisation</a:t>
-            </a:r>
-            <a:endParaRPr lang="en-US" sz="1450" dirty="0"/>
-          </a:p>
-          <a:p>
-            <a:pPr marL="203200" indent="-203200">
-              <a:spcAft>
-                <a:spcPts val="1400"/>
-              </a:spcAft>
-              <a:buSzPct val="100000"/>
-              <a:buChar char="•"/>
-            </a:pPr>
-            <a:r>
-              <a:rPr lang="en-US" sz="1450" dirty="0">
-                <a:solidFill>
-                  <a:srgbClr val="12262B"/>
-                </a:solidFill>
-                <a:latin typeface="Calibri" pitchFamily="34" charset="0"/>
-                <a:ea typeface="Calibri" pitchFamily="34" charset="-122"/>
-                <a:cs typeface="Calibri" pitchFamily="34" charset="-120"/>
-              </a:rPr>
-              <a:t>Statistical association only</a:t>
-            </a:r>
-            <a:endParaRPr lang="en-US" sz="1450" dirty="0"/>
-          </a:p>
-        </p:txBody>
-      </p:sp>
-      <p:sp>
-        <p:nvSpPr>
-          <p:cNvPr id="10" name="Shape 7"/>
-          <p:cNvSpPr/>
-          <p:nvPr/>
-        </p:nvSpPr>
-        <p:spPr>
-          <a:xfrm>
-            <a:off x="6309360" y="1828800"/>
-            <a:ext cx="5486400" cy="4023360"/>
-          </a:xfrm>
-          <a:prstGeom prst="roundRect">
-            <a:avLst>
-              <a:gd name="adj" fmla="val 1818"/>
-            </a:avLst>
-          </a:prstGeom>
-          <a:solidFill>
-            <a:srgbClr val="DCEEE4"/>
-          </a:solidFill>
-          <a:ln/>
-          <a:effectLst>
-            <a:outerShdw blurRad="88900" dist="38100" dir="5400000" algn="bl" rotWithShape="0">
-              <a:srgbClr val="000000">
-                <a:alpha val="12000"/>
-              </a:srgbClr>
-            </a:outerShdw>
-          </a:effectLst>
-        </p:spPr>
-      </p:sp>
-      <p:sp>
-        <p:nvSpPr>
-          <p:cNvPr id="11" name="Text 8"/>
-          <p:cNvSpPr/>
-          <p:nvPr/>
-        </p:nvSpPr>
-        <p:spPr>
-          <a:xfrm>
-            <a:off x="6675120" y="2057400"/>
-            <a:ext cx="4754880" cy="457200"/>
-          </a:xfrm>
-          <a:prstGeom prst="rect">
-            <a:avLst/>
-          </a:prstGeom>
-          <a:noFill/>
-          <a:ln/>
-        </p:spPr>
-        <p:txBody>
-          <a:bodyPr wrap="square" lIns="0" tIns="0" rIns="0" bIns="0" rtlCol="0" anchor="ctr"/>
-          <a:lstStyle/>
-          <a:p>
-            <a:pPr marL="0" indent="0">
-              <a:buNone/>
-            </a:pPr>
-            <a:r>
-              <a:rPr lang="en-US" sz="2000" b="1" dirty="0">
-                <a:solidFill>
-                  <a:srgbClr val="2E7D57"/>
-                </a:solidFill>
-                <a:latin typeface="Cambria" pitchFamily="34" charset="0"/>
-                <a:ea typeface="Cambria" pitchFamily="34" charset="-122"/>
-                <a:cs typeface="Cambria" pitchFamily="34" charset="-120"/>
-              </a:rPr>
-              <a:t>Validated</a:t>
-            </a:r>
-            <a:endParaRPr lang="en-US" sz="2000" dirty="0"/>
-          </a:p>
-        </p:txBody>
-      </p:sp>
-      <p:sp>
-        <p:nvSpPr>
-          <p:cNvPr id="12" name="Text 9"/>
-          <p:cNvSpPr/>
-          <p:nvPr/>
-        </p:nvSpPr>
-        <p:spPr>
-          <a:xfrm>
-            <a:off x="6675120" y="2697480"/>
-            <a:ext cx="4754880" cy="2926080"/>
-          </a:xfrm>
-          <a:prstGeom prst="rect">
-            <a:avLst/>
-          </a:prstGeom>
-          <a:noFill/>
-          <a:ln/>
-        </p:spPr>
-        <p:txBody>
-          <a:bodyPr wrap="square" lIns="0" tIns="0" rIns="0" bIns="0" rtlCol="0" anchor="t"/>
-          <a:lstStyle/>
-          <a:p>
-            <a:pPr marL="203200" indent="-203200">
-              <a:spcAft>
-                <a:spcPts val="1400"/>
-              </a:spcAft>
-              <a:buSzPct val="100000"/>
-              <a:buChar char="•"/>
-            </a:pPr>
-            <a:r>
-              <a:rPr lang="en-US" sz="1450" dirty="0">
-                <a:solidFill>
-                  <a:srgbClr val="12262B"/>
-                </a:solidFill>
-                <a:latin typeface="Calibri" pitchFamily="34" charset="0"/>
-                <a:ea typeface="Calibri" pitchFamily="34" charset="-122"/>
-                <a:cs typeface="Calibri" pitchFamily="34" charset="-120"/>
-              </a:rPr>
-              <a:t>Pre-specified, locked-down signature</a:t>
-            </a:r>
-            <a:endParaRPr lang="en-US" sz="1450" dirty="0"/>
-          </a:p>
-          <a:p>
-            <a:pPr marL="203200" indent="-203200">
-              <a:spcAft>
-                <a:spcPts val="1400"/>
-              </a:spcAft>
-              <a:buSzPct val="100000"/>
-              <a:buChar char="•"/>
-            </a:pPr>
-            <a:r>
-              <a:rPr lang="en-US" sz="1450" dirty="0">
-                <a:solidFill>
-                  <a:srgbClr val="12262B"/>
-                </a:solidFill>
-                <a:latin typeface="Calibri" pitchFamily="34" charset="0"/>
-                <a:ea typeface="Calibri" pitchFamily="34" charset="-122"/>
-                <a:cs typeface="Calibri" pitchFamily="34" charset="-120"/>
-              </a:rPr>
-              <a:t>Independent multi-cohort validation</a:t>
-            </a:r>
-            <a:endParaRPr lang="en-US" sz="1450" dirty="0"/>
-          </a:p>
-          <a:p>
-            <a:pPr marL="203200" indent="-203200">
-              <a:spcAft>
-                <a:spcPts val="1400"/>
-              </a:spcAft>
-              <a:buSzPct val="100000"/>
-              <a:buChar char="•"/>
-            </a:pPr>
-            <a:r>
-              <a:rPr lang="en-US" sz="1450" dirty="0">
-                <a:solidFill>
-                  <a:srgbClr val="12262B"/>
-                </a:solidFill>
-                <a:latin typeface="Calibri" pitchFamily="34" charset="0"/>
-                <a:ea typeface="Calibri" pitchFamily="34" charset="-122"/>
-                <a:cs typeface="Calibri" pitchFamily="34" charset="-120"/>
-              </a:rPr>
-              <a:t>Demonstrated clinical utility, not just association</a:t>
-            </a:r>
-            <a:endParaRPr lang="en-US" sz="1450" dirty="0"/>
-          </a:p>
-          <a:p>
-            <a:pPr marL="203200" indent="-203200">
-              <a:spcAft>
-                <a:spcPts val="1400"/>
-              </a:spcAft>
-              <a:buSzPct val="100000"/>
-              <a:buChar char="•"/>
-            </a:pPr>
-            <a:r>
-              <a:rPr lang="en-US" sz="1450" dirty="0">
-                <a:solidFill>
-                  <a:srgbClr val="12262B"/>
-                </a:solidFill>
-                <a:latin typeface="Calibri" pitchFamily="34" charset="0"/>
-                <a:ea typeface="Calibri" pitchFamily="34" charset="-122"/>
-                <a:cs typeface="Calibri" pitchFamily="34" charset="-120"/>
-              </a:rPr>
-              <a:t>Reproducible, documented pipeline</a:t>
-            </a:r>
-            <a:endParaRPr lang="en-US" sz="1450" dirty="0"/>
-          </a:p>
-        </p:txBody>
-      </p:sp>
-    </p:spTree>
-  </p:cSld>
-  <p:clrMapOvr>
-    <a:masterClrMapping/>
-  </p:clrMapOvr>
-</p:sld>
-</file>
-
-<file path=ppt/slides/slide21.xml><?xml version="1.0" encoding="utf-8"?>
-<p:sld xmlns:a="http://schemas.openxmlformats.org/drawingml/2006/main" xmlns:r="http://schemas.openxmlformats.org/officeDocument/2006/relationships" xmlns:p="http://schemas.openxmlformats.org/presentationml/2006/main">
   <p:cSld name="Slide 21">
     <p:bg>
       <p:bgPr>
@@ -18637,7 +18175,7 @@
 </p:sld>
 </file>
 
-<file path=ppt/slides/slide22.xml><?xml version="1.0" encoding="utf-8"?>
+<file path=ppt/slides/slide21.xml><?xml version="1.0" encoding="utf-8"?>
 <p:sld xmlns:a="http://schemas.openxmlformats.org/drawingml/2006/main" xmlns:r="http://schemas.openxmlformats.org/officeDocument/2006/relationships" xmlns:p="http://schemas.openxmlformats.org/presentationml/2006/main">
   <p:cSld name="Slide 22">
     <p:bg>
@@ -18826,7 +18364,7 @@
         </p:nvSpPr>
         <p:spPr>
           <a:xfrm>
-            <a:off x="822960" y="1920240"/>
+            <a:off x="809106" y="1379913"/>
             <a:ext cx="10058400" cy="1143000"/>
           </a:xfrm>
           <a:prstGeom prst="roundRect">
@@ -18855,7 +18393,7 @@
         </p:nvSpPr>
         <p:spPr>
           <a:xfrm>
-            <a:off x="822960" y="1920240"/>
+            <a:off x="809106" y="1379913"/>
             <a:ext cx="10058400" cy="1143000"/>
           </a:xfrm>
           <a:prstGeom prst="roundRect">
@@ -18882,7 +18420,7 @@
         </p:nvSpPr>
         <p:spPr>
           <a:xfrm>
-            <a:off x="822960" y="1920240"/>
+            <a:off x="809106" y="1379913"/>
             <a:ext cx="2560320" cy="1143000"/>
           </a:xfrm>
           <a:prstGeom prst="roundRect">
@@ -18904,7 +18442,7 @@
         </p:nvSpPr>
         <p:spPr>
           <a:xfrm>
-            <a:off x="822960" y="1920240"/>
+            <a:off x="809106" y="1379913"/>
             <a:ext cx="2560320" cy="1143000"/>
           </a:xfrm>
           <a:prstGeom prst="rect">
@@ -18943,7 +18481,7 @@
         </p:nvSpPr>
         <p:spPr>
           <a:xfrm>
-            <a:off x="3657600" y="2057400"/>
+            <a:off x="3643746" y="1517073"/>
             <a:ext cx="7040880" cy="548640"/>
           </a:xfrm>
           <a:prstGeom prst="rect">
@@ -18982,7 +18520,7 @@
         </p:nvSpPr>
         <p:spPr>
           <a:xfrm>
-            <a:off x="3657600" y="2487168"/>
+            <a:off x="3643746" y="1946841"/>
             <a:ext cx="7040880" cy="457200"/>
           </a:xfrm>
           <a:prstGeom prst="rect">
@@ -19021,7 +18559,7 @@
         </p:nvSpPr>
         <p:spPr>
           <a:xfrm>
-            <a:off x="822960" y="3264408"/>
+            <a:off x="809106" y="2724081"/>
             <a:ext cx="10058400" cy="1143000"/>
           </a:xfrm>
           <a:prstGeom prst="roundRect">
@@ -19050,7 +18588,7 @@
         </p:nvSpPr>
         <p:spPr>
           <a:xfrm>
-            <a:off x="822960" y="3264408"/>
+            <a:off x="809106" y="2724081"/>
             <a:ext cx="10058400" cy="1143000"/>
           </a:xfrm>
           <a:prstGeom prst="roundRect">
@@ -19077,7 +18615,7 @@
         </p:nvSpPr>
         <p:spPr>
           <a:xfrm>
-            <a:off x="822960" y="3264408"/>
+            <a:off x="809106" y="2724081"/>
             <a:ext cx="2560320" cy="1143000"/>
           </a:xfrm>
           <a:prstGeom prst="roundRect">
@@ -19099,7 +18637,7 @@
         </p:nvSpPr>
         <p:spPr>
           <a:xfrm>
-            <a:off x="822960" y="3264408"/>
+            <a:off x="809106" y="2724081"/>
             <a:ext cx="2560320" cy="1143000"/>
           </a:xfrm>
           <a:prstGeom prst="rect">
@@ -19138,7 +18676,7 @@
         </p:nvSpPr>
         <p:spPr>
           <a:xfrm>
-            <a:off x="3657600" y="3401568"/>
+            <a:off x="3643746" y="2861241"/>
             <a:ext cx="7040880" cy="548640"/>
           </a:xfrm>
           <a:prstGeom prst="rect">
@@ -19177,7 +18715,7 @@
         </p:nvSpPr>
         <p:spPr>
           <a:xfrm>
-            <a:off x="3657600" y="3831336"/>
+            <a:off x="3643746" y="3291009"/>
             <a:ext cx="7040880" cy="457200"/>
           </a:xfrm>
           <a:prstGeom prst="rect">
@@ -19202,7 +18740,7 @@
                 <a:ea typeface="Calibri" pitchFamily="34" charset="-122"/>
                 <a:cs typeface="Calibri" pitchFamily="34" charset="-120"/>
               </a:rPr>
-              <a:t>used many times</a:t>
+              <a:t>used many times: it gives you optimistic performance as you used it to make choices</a:t>
             </a:r>
             <a:endParaRPr lang="en-US" sz="1200" dirty="0"/>
           </a:p>
@@ -19216,7 +18754,7 @@
         </p:nvSpPr>
         <p:spPr>
           <a:xfrm>
-            <a:off x="822960" y="4608576"/>
+            <a:off x="809106" y="4068249"/>
             <a:ext cx="10058400" cy="1143000"/>
           </a:xfrm>
           <a:prstGeom prst="roundRect">
@@ -19245,7 +18783,7 @@
         </p:nvSpPr>
         <p:spPr>
           <a:xfrm>
-            <a:off x="822960" y="4608576"/>
+            <a:off x="809106" y="4068249"/>
             <a:ext cx="10058400" cy="1143000"/>
           </a:xfrm>
           <a:prstGeom prst="roundRect">
@@ -19272,7 +18810,7 @@
         </p:nvSpPr>
         <p:spPr>
           <a:xfrm>
-            <a:off x="822960" y="4608576"/>
+            <a:off x="809106" y="4068249"/>
             <a:ext cx="2560320" cy="1143000"/>
           </a:xfrm>
           <a:prstGeom prst="roundRect">
@@ -19294,7 +18832,7 @@
         </p:nvSpPr>
         <p:spPr>
           <a:xfrm>
-            <a:off x="822960" y="4608576"/>
+            <a:off x="809106" y="4068249"/>
             <a:ext cx="2560320" cy="1143000"/>
           </a:xfrm>
           <a:prstGeom prst="rect">
@@ -19333,7 +18871,7 @@
         </p:nvSpPr>
         <p:spPr>
           <a:xfrm>
-            <a:off x="3657600" y="4745736"/>
+            <a:off x="3643746" y="4205409"/>
             <a:ext cx="7040880" cy="548640"/>
           </a:xfrm>
           <a:prstGeom prst="rect">
@@ -19372,7 +18910,7 @@
         </p:nvSpPr>
         <p:spPr>
           <a:xfrm>
-            <a:off x="3657600" y="5175504"/>
+            <a:off x="3643746" y="4635177"/>
             <a:ext cx="7040880" cy="457200"/>
           </a:xfrm>
           <a:prstGeom prst="rect">
@@ -19411,7 +18949,7 @@
         </p:nvSpPr>
         <p:spPr>
           <a:xfrm>
-            <a:off x="822960" y="5998464"/>
+            <a:off x="809106" y="5458137"/>
             <a:ext cx="10058400" cy="365760"/>
           </a:xfrm>
           <a:prstGeom prst="rect">
@@ -19439,6 +18977,54 @@
               <a:t>In small cohorts, cross-validation replaces a fixed validation set (preview only).</a:t>
             </a:r>
             <a:endParaRPr lang="en-US" sz="1250" dirty="0"/>
+          </a:p>
+        </p:txBody>
+      </p:sp>
+      <p:sp>
+        <p:nvSpPr>
+          <p:cNvPr id="26" name="TextBox 25">
+            <a:extLst>
+              <a:ext uri="{FF2B5EF4-FFF2-40B4-BE49-F238E27FC236}">
+                <a16:creationId xmlns:a16="http://schemas.microsoft.com/office/drawing/2014/main" id="{5D150910-7BEE-13B8-D28A-B4FCE471324B}"/>
+              </a:ext>
+            </a:extLst>
+          </p:cNvPr>
+          <p:cNvSpPr txBox="1"/>
+          <p:nvPr/>
+        </p:nvSpPr>
+        <p:spPr>
+          <a:xfrm>
+            <a:off x="1878676" y="6041106"/>
+            <a:ext cx="9185564" cy="369332"/>
+          </a:xfrm>
+          <a:prstGeom prst="rect">
+            <a:avLst/>
+          </a:prstGeom>
+          <a:noFill/>
+        </p:spPr>
+        <p:txBody>
+          <a:bodyPr wrap="square">
+            <a:spAutoFit/>
+          </a:bodyPr>
+          <a:lstStyle/>
+          <a:p>
+            <a:pPr>
+              <a:spcAft>
+                <a:spcPts val="1300"/>
+              </a:spcAft>
+              <a:buSzPct val="100000"/>
+            </a:pPr>
+            <a:r>
+              <a:rPr lang="en-US" sz="1800" b="1" dirty="0">
+                <a:solidFill>
+                  <a:srgbClr val="0E7C86"/>
+                </a:solidFill>
+                <a:latin typeface="Calibri" pitchFamily="34" charset="0"/>
+                <a:ea typeface="Calibri" pitchFamily="34" charset="-122"/>
+                <a:cs typeface="Calibri" pitchFamily="34" charset="-120"/>
+              </a:rPr>
+              <a:t>QUESTION: what happens if I look at the test set multiple times as “sanity” check?</a:t>
+            </a:r>
           </a:p>
         </p:txBody>
       </p:sp>
@@ -19450,7 +19036,7 @@
 </p:sld>
 </file>
 
-<file path=ppt/slides/slide23.xml><?xml version="1.0" encoding="utf-8"?>
+<file path=ppt/slides/slide22.xml><?xml version="1.0" encoding="utf-8"?>
 <p:sld xmlns:a="http://schemas.openxmlformats.org/drawingml/2006/main" xmlns:r="http://schemas.openxmlformats.org/officeDocument/2006/relationships" xmlns:p="http://schemas.openxmlformats.org/presentationml/2006/main">
   <p:cSld name="Slide 23">
     <p:bg>
@@ -20097,7 +19683,7 @@
 </p:sld>
 </file>
 
-<file path=ppt/slides/slide24.xml><?xml version="1.0" encoding="utf-8"?>
+<file path=ppt/slides/slide23.xml><?xml version="1.0" encoding="utf-8"?>
 <p:sld xmlns:a="http://schemas.openxmlformats.org/drawingml/2006/main" xmlns:r="http://schemas.openxmlformats.org/officeDocument/2006/relationships" xmlns:p="http://schemas.openxmlformats.org/presentationml/2006/main">
   <p:cSld name="Slide 24">
     <p:bg>
@@ -20239,7 +19825,7 @@
                 <a:ea typeface="Calibri" pitchFamily="34" charset="-122"/>
                 <a:cs typeface="Calibri" pitchFamily="34" charset="-120"/>
               </a:rPr>
-              <a:t>The hard part is the science around the model — the question, the label, the data structure, the splits, the validation.</a:t>
+              <a:t>The hard part is the science around the model : the question, the label, the data structure, the splits, the validation.</a:t>
             </a:r>
             <a:endParaRPr lang="en-US" sz="1600" dirty="0"/>
           </a:p>
@@ -20256,7 +19842,29 @@
                 <a:ea typeface="Calibri" pitchFamily="34" charset="-122"/>
                 <a:cs typeface="Calibri" pitchFamily="34" charset="-120"/>
               </a:rPr>
-              <a:t>A simple model on a clean, leak-free, validated pipeline beats a fancy model on a compromised one — every time.</a:t>
+              <a:t>A simple model on a clean, leak-free, validated pipeline beats a fancy model on a </a:t>
+            </a:r>
+            <a:r>
+              <a:rPr lang="en-US" sz="1600">
+                <a:solidFill>
+                  <a:srgbClr val="DCEDEE"/>
+                </a:solidFill>
+                <a:latin typeface="Calibri" pitchFamily="34" charset="0"/>
+                <a:ea typeface="Calibri" pitchFamily="34" charset="-122"/>
+                <a:cs typeface="Calibri" pitchFamily="34" charset="-120"/>
+              </a:rPr>
+              <a:t>compromised one, every </a:t>
+            </a:r>
+            <a:r>
+              <a:rPr lang="en-US" sz="1600" dirty="0">
+                <a:solidFill>
+                  <a:srgbClr val="DCEDEE"/>
+                </a:solidFill>
+                <a:latin typeface="Calibri" pitchFamily="34" charset="0"/>
+                <a:ea typeface="Calibri" pitchFamily="34" charset="-122"/>
+                <a:cs typeface="Calibri" pitchFamily="34" charset="-120"/>
+              </a:rPr>
+              <a:t>time.</a:t>
             </a:r>
             <a:endParaRPr lang="en-US" sz="1600" dirty="0"/>
           </a:p>
@@ -20270,7 +19878,7 @@
 </p:sld>
 </file>
 
-<file path=ppt/slides/slide25.xml><?xml version="1.0" encoding="utf-8"?>
+<file path=ppt/slides/slide24.xml><?xml version="1.0" encoding="utf-8"?>
 <p:sld xmlns:a="http://schemas.openxmlformats.org/drawingml/2006/main" xmlns:r="http://schemas.openxmlformats.org/officeDocument/2006/relationships" xmlns:p="http://schemas.openxmlformats.org/presentationml/2006/main">
   <p:cSld name="Slide 25">
     <p:bg>
@@ -23174,7 +22782,7 @@
         </p:nvSpPr>
         <p:spPr>
           <a:xfrm>
-            <a:off x="548640" y="1828800"/>
+            <a:off x="579120" y="1627632"/>
             <a:ext cx="5669280" cy="4206240"/>
           </a:xfrm>
           <a:prstGeom prst="rect">
@@ -23224,7 +22832,7 @@
                 <a:ea typeface="Calibri" pitchFamily="34" charset="-122"/>
                 <a:cs typeface="Calibri" pitchFamily="34" charset="-120"/>
               </a:rPr>
-              <a:t>This is not yet a machine learning problem — it is underspecified.</a:t>
+              <a:t>This is not yet a well made machine learning problem, it is underspecified.</a:t>
             </a:r>
             <a:endParaRPr lang="en-US" sz="1600" dirty="0"/>
           </a:p>
@@ -23245,7 +22853,29 @@
                 <a:ea typeface="Calibri" pitchFamily="34" charset="-122"/>
                 <a:cs typeface="Calibri" pitchFamily="34" charset="-120"/>
               </a:rPr>
-              <a:t>To make it ML-shaped, commit to four things: what we measure (input), what we predict (output), when we measure it, and on whom.</a:t>
+              <a:t>To make it ML-ready, we need 4 </a:t>
+            </a:r>
+            <a:r>
+              <a:rPr lang="en-US" sz="1600" dirty="0" err="1">
+                <a:solidFill>
+                  <a:srgbClr val="12262B"/>
+                </a:solidFill>
+                <a:latin typeface="Calibri" pitchFamily="34" charset="0"/>
+                <a:ea typeface="Calibri" pitchFamily="34" charset="-122"/>
+                <a:cs typeface="Calibri" pitchFamily="34" charset="-120"/>
+              </a:rPr>
+              <a:t>ingrediants</a:t>
+            </a:r>
+            <a:r>
+              <a:rPr lang="en-US" sz="1600" dirty="0">
+                <a:solidFill>
+                  <a:srgbClr val="12262B"/>
+                </a:solidFill>
+                <a:latin typeface="Calibri" pitchFamily="34" charset="0"/>
+                <a:ea typeface="Calibri" pitchFamily="34" charset="-122"/>
+                <a:cs typeface="Calibri" pitchFamily="34" charset="-120"/>
+              </a:rPr>
+              <a:t>: what we measure (input), what we predict (output), when we measure it, and on whom.</a:t>
             </a:r>
             <a:endParaRPr lang="en-US" sz="1600" dirty="0"/>
           </a:p>
@@ -23266,9 +22896,44 @@
                 <a:ea typeface="Calibri" pitchFamily="34" charset="-122"/>
                 <a:cs typeface="Calibri" pitchFamily="34" charset="-120"/>
               </a:rPr>
-              <a:t>Most of the scientific judgement — and the danger — lives in this translation step, not the model.</a:t>
+              <a:t>Most of the scientific decisions and the danger lives in this translation step, not the model.</a:t>
+            </a:r>
+          </a:p>
+          <a:p>
+            <a:pPr marL="203200" indent="-203200">
+              <a:spcAft>
+                <a:spcPts val="1400"/>
+              </a:spcAft>
+              <a:buSzPct val="100000"/>
+              <a:buChar char="•"/>
+            </a:pPr>
+            <a:r>
+              <a:rPr lang="en-US" sz="1600" b="1" dirty="0">
+                <a:solidFill>
+                  <a:srgbClr val="0E7C86"/>
+                </a:solidFill>
+                <a:latin typeface="Calibri" pitchFamily="34" charset="0"/>
+                <a:cs typeface="Calibri" pitchFamily="34" charset="-120"/>
+              </a:rPr>
+              <a:t>Try to not let the data decide the question!</a:t>
             </a:r>
             <a:endParaRPr lang="en-US" sz="1600" dirty="0"/>
+          </a:p>
+          <a:p>
+            <a:pPr marL="203200" indent="-203200">
+              <a:spcAft>
+                <a:spcPts val="1400"/>
+              </a:spcAft>
+              <a:buSzPct val="100000"/>
+              <a:buChar char="•"/>
+            </a:pPr>
+            <a:endParaRPr lang="en-US" sz="1600" b="1" dirty="0">
+              <a:solidFill>
+                <a:srgbClr val="0E7C86"/>
+              </a:solidFill>
+              <a:latin typeface="Calibri" pitchFamily="34" charset="0"/>
+              <a:cs typeface="Calibri" pitchFamily="34" charset="-120"/>
+            </a:endParaRPr>
           </a:p>
         </p:txBody>
       </p:sp>
@@ -23810,7 +23475,7 @@
           <p:nvPr>
             <p:extLst>
               <p:ext uri="{D42A27DB-BD31-4B8C-83A1-F6EECF244321}">
-                <p14:modId xmlns:p14="http://schemas.microsoft.com/office/powerpoint/2010/main" val="1579011935"/>
+                <p14:modId xmlns:p14="http://schemas.microsoft.com/office/powerpoint/2010/main" val="3297015153"/>
               </p:ext>
             </p:extLst>
           </p:nvPr>
@@ -24279,20 +23944,86 @@
                       </a:pPr>
                       <a:r>
                         <a:rPr lang="en-US" sz="1250" dirty="0">
-                          <a:solidFill>
-                            <a:srgbClr val="12262B"/>
-                          </a:solidFill>
-                          <a:latin typeface="Calibri" pitchFamily="34" charset="0"/>
-                          <a:ea typeface="Calibri" pitchFamily="34" charset="-122"/>
-                          <a:cs typeface="Calibri" pitchFamily="34" charset="-120"/>
+                          <a:latin typeface="Calibri" charset="0"/>
+                          <a:ea typeface="Calibri" charset="0"/>
+                          <a:cs typeface="Calibri" charset="0"/>
                         </a:rPr>
-                        <a:t>RCB class</a:t>
+                        <a:t>Clinical Benefit</a:t>
                       </a:r>
-                      <a:endParaRPr lang="en-US" sz="1250" dirty="0">
-                        <a:latin typeface="Calibri" charset="0"/>
-                        <a:ea typeface="Calibri" charset="0"/>
-                        <a:cs typeface="Calibri" charset="0"/>
-                      </a:endParaRPr>
+                    </a:p>
+                  </a:txBody>
+                  <a:tcPr marL="76200" marR="76200" marT="76200" marB="76200" anchor="ctr">
+                    <a:lnL w="12700" cap="flat" cmpd="sng" algn="ctr">
+                      <a:solidFill>
+                        <a:srgbClr val="C9D7D9"/>
+                      </a:solidFill>
+                      <a:prstDash val="solid"/>
+                      <a:round/>
+                      <a:headEnd type="none" w="med" len="med"/>
+                      <a:tailEnd type="none" w="med" len="med"/>
+                    </a:lnL>
+                    <a:lnR w="12700" cap="flat" cmpd="sng" algn="ctr">
+                      <a:solidFill>
+                        <a:srgbClr val="C9D7D9"/>
+                      </a:solidFill>
+                      <a:prstDash val="solid"/>
+                      <a:round/>
+                      <a:headEnd type="none" w="med" len="med"/>
+                      <a:tailEnd type="none" w="med" len="med"/>
+                    </a:lnR>
+                    <a:lnT w="12700" cap="flat" cmpd="sng" algn="ctr">
+                      <a:solidFill>
+                        <a:srgbClr val="C9D7D9"/>
+                      </a:solidFill>
+                      <a:prstDash val="solid"/>
+                      <a:round/>
+                      <a:headEnd type="none" w="med" len="med"/>
+                      <a:tailEnd type="none" w="med" len="med"/>
+                    </a:lnT>
+                    <a:lnB w="12700" cap="flat" cmpd="sng" algn="ctr">
+                      <a:solidFill>
+                        <a:srgbClr val="C9D7D9"/>
+                      </a:solidFill>
+                      <a:prstDash val="solid"/>
+                      <a:round/>
+                      <a:headEnd type="none" w="med" len="med"/>
+                      <a:tailEnd type="none" w="med" len="med"/>
+                    </a:lnB>
+                    <a:solidFill>
+                      <a:srgbClr val="FFFFFF"/>
+                    </a:solidFill>
+                  </a:tcPr>
+                </a:tc>
+                <a:tc>
+                  <a:txBody>
+                    <a:bodyPr/>
+                    <a:lstStyle/>
+                    <a:p>
+                      <a:pPr marL="0" marR="0" indent="0" algn="l" defTabSz="914400" rtl="0" eaLnBrk="1" fontAlgn="auto" latinLnBrk="0" hangingPunct="1">
+                        <a:lnSpc>
+                          <a:spcPct val="100000"/>
+                        </a:lnSpc>
+                        <a:spcBef>
+                          <a:spcPts val="0"/>
+                        </a:spcBef>
+                        <a:spcAft>
+                          <a:spcPts val="0"/>
+                        </a:spcAft>
+                        <a:buClrTx/>
+                        <a:buSzTx/>
+                        <a:buFontTx/>
+                        <a:buNone/>
+                        <a:tabLst/>
+                        <a:defRPr/>
+                      </a:pPr>
+                      <a:r>
+                        <a:rPr lang="en-US" sz="1250" dirty="0">
+                          <a:latin typeface="Calibri" charset="0"/>
+                          <a:ea typeface="Calibri" charset="0"/>
+                          <a:cs typeface="Calibri" charset="0"/>
+                        </a:rPr>
+                        <a:t>Only with a comparator arm (treated-vs-untreated)</a:t>
+                      </a:r>
                     </a:p>
                   </a:txBody>
                   <a:tcPr marL="76200" marR="76200" marT="76200" marB="76200" anchor="ctr">
@@ -24347,88 +24078,12 @@
                       </a:pPr>
                       <a:r>
                         <a:rPr lang="en-US" sz="1250" dirty="0">
-                          <a:solidFill>
-                            <a:srgbClr val="12262B"/>
-                          </a:solidFill>
-                          <a:latin typeface="Calibri" pitchFamily="34" charset="0"/>
-                          <a:ea typeface="Calibri" pitchFamily="34" charset="-122"/>
-                          <a:cs typeface="Calibri" pitchFamily="34" charset="-120"/>
+                          <a:latin typeface="Calibri" charset="0"/>
+                          <a:ea typeface="Calibri" charset="0"/>
+                          <a:cs typeface="Calibri" charset="0"/>
                         </a:rPr>
-                        <a:t>Early (at surgery)</a:t>
+                        <a:t>Needs untreated patients; not learnable from single-arm data</a:t>
                       </a:r>
-                      <a:endParaRPr lang="en-US" sz="1250" dirty="0">
-                        <a:latin typeface="Calibri" charset="0"/>
-                        <a:ea typeface="Calibri" charset="0"/>
-                        <a:cs typeface="Calibri" charset="0"/>
-                      </a:endParaRPr>
-                    </a:p>
-                  </a:txBody>
-                  <a:tcPr marL="76200" marR="76200" marT="76200" marB="76200" anchor="ctr">
-                    <a:lnL w="12700" cap="flat" cmpd="sng" algn="ctr">
-                      <a:solidFill>
-                        <a:srgbClr val="C9D7D9"/>
-                      </a:solidFill>
-                      <a:prstDash val="solid"/>
-                      <a:round/>
-                      <a:headEnd type="none" w="med" len="med"/>
-                      <a:tailEnd type="none" w="med" len="med"/>
-                    </a:lnL>
-                    <a:lnR w="12700" cap="flat" cmpd="sng" algn="ctr">
-                      <a:solidFill>
-                        <a:srgbClr val="C9D7D9"/>
-                      </a:solidFill>
-                      <a:prstDash val="solid"/>
-                      <a:round/>
-                      <a:headEnd type="none" w="med" len="med"/>
-                      <a:tailEnd type="none" w="med" len="med"/>
-                    </a:lnR>
-                    <a:lnT w="12700" cap="flat" cmpd="sng" algn="ctr">
-                      <a:solidFill>
-                        <a:srgbClr val="C9D7D9"/>
-                      </a:solidFill>
-                      <a:prstDash val="solid"/>
-                      <a:round/>
-                      <a:headEnd type="none" w="med" len="med"/>
-                      <a:tailEnd type="none" w="med" len="med"/>
-                    </a:lnT>
-                    <a:lnB w="12700" cap="flat" cmpd="sng" algn="ctr">
-                      <a:solidFill>
-                        <a:srgbClr val="C9D7D9"/>
-                      </a:solidFill>
-                      <a:prstDash val="solid"/>
-                      <a:round/>
-                      <a:headEnd type="none" w="med" len="med"/>
-                      <a:tailEnd type="none" w="med" len="med"/>
-                    </a:lnB>
-                    <a:solidFill>
-                      <a:srgbClr val="FFFFFF"/>
-                    </a:solidFill>
-                  </a:tcPr>
-                </a:tc>
-                <a:tc>
-                  <a:txBody>
-                    <a:bodyPr/>
-                    <a:lstStyle/>
-                    <a:p>
-                      <a:pPr marL="0" indent="0" algn="l">
-                        <a:buNone/>
-                      </a:pPr>
-                      <a:r>
-                        <a:rPr lang="en-US" sz="1250" dirty="0">
-                          <a:solidFill>
-                            <a:srgbClr val="12262B"/>
-                          </a:solidFill>
-                          <a:latin typeface="Calibri" pitchFamily="34" charset="0"/>
-                          <a:ea typeface="Calibri" pitchFamily="34" charset="-122"/>
-                          <a:cs typeface="Calibri" pitchFamily="34" charset="-120"/>
-                        </a:rPr>
-                        <a:t>Graded, but same surrogacy concern</a:t>
-                      </a:r>
-                      <a:endParaRPr lang="en-US" sz="1250" dirty="0">
-                        <a:latin typeface="Calibri" charset="0"/>
-                        <a:ea typeface="Calibri" charset="0"/>
-                        <a:cs typeface="Calibri" charset="0"/>
-                      </a:endParaRPr>
                     </a:p>
                   </a:txBody>
                   <a:tcPr marL="76200" marR="76200" marT="76200" marB="76200" anchor="ctr">
@@ -24696,45 +24351,6 @@
       </p:graphicFrame>
       <p:sp>
         <p:nvSpPr>
-          <p:cNvPr id="8" name="Text 4"/>
-          <p:cNvSpPr/>
-          <p:nvPr/>
-        </p:nvSpPr>
-        <p:spPr>
-          <a:xfrm>
-            <a:off x="548640" y="4297680"/>
-            <a:ext cx="6858000" cy="320040"/>
-          </a:xfrm>
-          <a:prstGeom prst="rect">
-            <a:avLst/>
-          </a:prstGeom>
-          <a:noFill/>
-          <a:ln/>
-        </p:spPr>
-        <p:txBody>
-          <a:bodyPr wrap="square" lIns="0" tIns="0" rIns="0" bIns="0" rtlCol="0" anchor="ctr"/>
-          <a:lstStyle/>
-          <a:p>
-            <a:pPr marL="0" indent="0">
-              <a:buNone/>
-            </a:pPr>
-            <a:r>
-              <a:rPr lang="en-US" sz="1200" i="1" dirty="0">
-                <a:solidFill>
-                  <a:srgbClr val="0E7C86"/>
-                </a:solidFill>
-                <a:latin typeface="Calibri" pitchFamily="34" charset="0"/>
-                <a:ea typeface="Calibri" pitchFamily="34" charset="-122"/>
-                <a:cs typeface="Calibri" pitchFamily="34" charset="-120"/>
-              </a:rPr>
-              <a:t>→ relapse / DMFS is “what our data supports.”</a:t>
-            </a:r>
-            <a:endParaRPr lang="en-US" sz="1200" dirty="0"/>
-          </a:p>
-        </p:txBody>
-      </p:sp>
-      <p:sp>
-        <p:nvSpPr>
           <p:cNvPr id="9" name="Shape 5"/>
           <p:cNvSpPr/>
           <p:nvPr/>
@@ -24834,7 +24450,29 @@
                 <a:ea typeface="Calibri" pitchFamily="34" charset="-122"/>
                 <a:cs typeface="Calibri" pitchFamily="34" charset="-120"/>
               </a:rPr>
-              <a:t>METABRIC is not neoadjuvant and has no pCR. The practical predicts relapse / recurrence from long-term survival data — the endpoint family used by the published HR+/HER2− model we follow.</a:t>
+              <a:t>METABRIC has long </a:t>
+            </a:r>
+            <a:r>
+              <a:rPr lang="en-US" sz="1150" dirty="0" err="1">
+                <a:solidFill>
+                  <a:srgbClr val="12262B"/>
+                </a:solidFill>
+                <a:latin typeface="Calibri" pitchFamily="34" charset="0"/>
+                <a:ea typeface="Calibri" pitchFamily="34" charset="-122"/>
+                <a:cs typeface="Calibri" pitchFamily="34" charset="-120"/>
+              </a:rPr>
+              <a:t>followup</a:t>
+            </a:r>
+            <a:r>
+              <a:rPr lang="en-US" sz="1150" dirty="0">
+                <a:solidFill>
+                  <a:srgbClr val="12262B"/>
+                </a:solidFill>
+                <a:latin typeface="Calibri" pitchFamily="34" charset="0"/>
+                <a:ea typeface="Calibri" pitchFamily="34" charset="-122"/>
+                <a:cs typeface="Calibri" pitchFamily="34" charset="-120"/>
+              </a:rPr>
+              <a:t>. The practical predicts relapse / recurrence from long-term survival data: this will be our endpoint.</a:t>
             </a:r>
             <a:endParaRPr lang="en-US" sz="1150" dirty="0"/>
           </a:p>
@@ -25195,7 +24833,7 @@
               <a:buNone/>
             </a:pPr>
             <a:r>
-              <a:rPr lang="en-US" sz="1200" dirty="0">
+              <a:rPr lang="en-US" sz="1200" b="1" dirty="0" err="1">
                 <a:solidFill>
                   <a:srgbClr val="12262B"/>
                 </a:solidFill>
@@ -25203,9 +24841,19 @@
                 <a:ea typeface="Calibri" pitchFamily="34" charset="-122"/>
                 <a:cs typeface="Calibri" pitchFamily="34" charset="-120"/>
               </a:rPr>
-              <a:t>Tumour biopsy</a:t>
-            </a:r>
-            <a:endParaRPr lang="en-US" sz="1200" dirty="0"/>
+              <a:t>Tumour</a:t>
+            </a:r>
+            <a:r>
+              <a:rPr lang="en-US" sz="1200" b="1" dirty="0">
+                <a:solidFill>
+                  <a:srgbClr val="12262B"/>
+                </a:solidFill>
+                <a:latin typeface="Calibri" pitchFamily="34" charset="0"/>
+                <a:ea typeface="Calibri" pitchFamily="34" charset="-122"/>
+                <a:cs typeface="Calibri" pitchFamily="34" charset="-120"/>
+              </a:rPr>
+              <a:t> biopsy</a:t>
+            </a:r>
           </a:p>
         </p:txBody>
       </p:sp>
@@ -25606,7 +25254,7 @@
         <p:spPr>
           <a:xfrm>
             <a:off x="548640" y="2907792"/>
-            <a:ext cx="11064240" cy="365760"/>
+            <a:ext cx="1993392" cy="365760"/>
           </a:xfrm>
           <a:prstGeom prst="rect">
             <a:avLst/>
@@ -25622,17 +25270,31 @@
               <a:buNone/>
             </a:pPr>
             <a:r>
-              <a:rPr lang="en-US" sz="1150" i="1" dirty="0">
-                <a:solidFill>
-                  <a:srgbClr val="5B6B70"/>
+              <a:rPr lang="en-US" sz="1100" dirty="0">
+                <a:solidFill>
+                  <a:srgbClr val="12262B"/>
                 </a:solidFill>
                 <a:latin typeface="Calibri" pitchFamily="34" charset="0"/>
-                <a:ea typeface="Calibri" pitchFamily="34" charset="-122"/>
                 <a:cs typeface="Calibri" pitchFamily="34" charset="-120"/>
               </a:rPr>
-              <a:t>each arrow adds choices &amp; artefacts: tumour content · RNA degradation · reagent lot · scanner · normalisation</a:t>
-            </a:r>
-            <a:endParaRPr lang="en-US" sz="1150" dirty="0"/>
+              <a:t>(which part, tumor content,</a:t>
+            </a:r>
+          </a:p>
+          <a:p>
+            <a:pPr marL="0" indent="0" algn="ctr">
+              <a:buNone/>
+            </a:pPr>
+            <a:r>
+              <a:rPr lang="en-US" sz="1100" dirty="0">
+                <a:solidFill>
+                  <a:srgbClr val="12262B"/>
+                </a:solidFill>
+                <a:latin typeface="Calibri" pitchFamily="34" charset="0"/>
+                <a:cs typeface="Calibri" pitchFamily="34" charset="-120"/>
+              </a:rPr>
+              <a:t>Preservation)</a:t>
+            </a:r>
+            <a:endParaRPr lang="en-US" sz="1100" dirty="0"/>
           </a:p>
         </p:txBody>
       </p:sp>
@@ -25715,7 +25377,29 @@
                 <a:ea typeface="Calibri" pitchFamily="34" charset="-122"/>
                 <a:cs typeface="Calibri" pitchFamily="34" charset="-120"/>
               </a:rPr>
-              <a:t>Each step injects potential artefacts — normalisation, platform, batch. Two cohorts on two platforms is exactly where batch effects are born.</a:t>
+              <a:t>Each step injects potential artefacts: </a:t>
+            </a:r>
+            <a:r>
+              <a:rPr lang="en-US" sz="1500" dirty="0" err="1">
+                <a:solidFill>
+                  <a:srgbClr val="12262B"/>
+                </a:solidFill>
+                <a:latin typeface="Calibri" pitchFamily="34" charset="0"/>
+                <a:ea typeface="Calibri" pitchFamily="34" charset="-122"/>
+                <a:cs typeface="Calibri" pitchFamily="34" charset="-120"/>
+              </a:rPr>
+              <a:t>normalisation</a:t>
+            </a:r>
+            <a:r>
+              <a:rPr lang="en-US" sz="1500" dirty="0">
+                <a:solidFill>
+                  <a:srgbClr val="12262B"/>
+                </a:solidFill>
+                <a:latin typeface="Calibri" pitchFamily="34" charset="0"/>
+                <a:ea typeface="Calibri" pitchFamily="34" charset="-122"/>
+                <a:cs typeface="Calibri" pitchFamily="34" charset="-120"/>
+              </a:rPr>
+              <a:t>, platform, batch. Two cohorts on two platforms is exactly where batch effects are born.</a:t>
             </a:r>
             <a:endParaRPr lang="en-US" sz="1500" dirty="0"/>
           </a:p>
@@ -25903,6 +25587,168 @@
               <a:t>Affymetrix series, combined in so a real cross-platform batch effect appears in the practical.</a:t>
             </a:r>
             <a:endParaRPr lang="en-US" sz="1200" dirty="0"/>
+          </a:p>
+        </p:txBody>
+      </p:sp>
+      <p:sp>
+        <p:nvSpPr>
+          <p:cNvPr id="29" name="Text 18">
+            <a:extLst>
+              <a:ext uri="{FF2B5EF4-FFF2-40B4-BE49-F238E27FC236}">
+                <a16:creationId xmlns:a16="http://schemas.microsoft.com/office/drawing/2014/main" id="{7EDE9598-E1BD-C279-70EB-237ED8FEDC6B}"/>
+              </a:ext>
+            </a:extLst>
+          </p:cNvPr>
+          <p:cNvSpPr/>
+          <p:nvPr/>
+        </p:nvSpPr>
+        <p:spPr>
+          <a:xfrm>
+            <a:off x="2779776" y="2861476"/>
+            <a:ext cx="1993392" cy="365760"/>
+          </a:xfrm>
+          <a:prstGeom prst="rect">
+            <a:avLst/>
+          </a:prstGeom>
+          <a:noFill/>
+          <a:ln/>
+        </p:spPr>
+        <p:txBody>
+          <a:bodyPr wrap="square" lIns="0" tIns="0" rIns="0" bIns="0" rtlCol="0" anchor="ctr"/>
+          <a:lstStyle/>
+          <a:p>
+            <a:pPr marL="0" indent="0" algn="ctr">
+              <a:buNone/>
+            </a:pPr>
+            <a:r>
+              <a:rPr lang="en-US" sz="1100" dirty="0">
+                <a:solidFill>
+                  <a:srgbClr val="12262B"/>
+                </a:solidFill>
+                <a:latin typeface="Calibri" pitchFamily="34" charset="0"/>
+                <a:cs typeface="Calibri" pitchFamily="34" charset="-120"/>
+              </a:rPr>
+              <a:t>Depends on preservation</a:t>
+            </a:r>
+            <a:endParaRPr lang="en-US" sz="1100" dirty="0"/>
+          </a:p>
+        </p:txBody>
+      </p:sp>
+      <p:sp>
+        <p:nvSpPr>
+          <p:cNvPr id="30" name="Text 18">
+            <a:extLst>
+              <a:ext uri="{FF2B5EF4-FFF2-40B4-BE49-F238E27FC236}">
+                <a16:creationId xmlns:a16="http://schemas.microsoft.com/office/drawing/2014/main" id="{9089BDCD-5221-4866-8A43-B8B664BC3FA5}"/>
+              </a:ext>
+            </a:extLst>
+          </p:cNvPr>
+          <p:cNvSpPr/>
+          <p:nvPr/>
+        </p:nvSpPr>
+        <p:spPr>
+          <a:xfrm>
+            <a:off x="5047488" y="2856109"/>
+            <a:ext cx="4169664" cy="365760"/>
+          </a:xfrm>
+          <a:prstGeom prst="rect">
+            <a:avLst/>
+          </a:prstGeom>
+          <a:noFill/>
+          <a:ln/>
+        </p:spPr>
+        <p:txBody>
+          <a:bodyPr wrap="square" lIns="0" tIns="0" rIns="0" bIns="0" rtlCol="0" anchor="ctr"/>
+          <a:lstStyle/>
+          <a:p>
+            <a:pPr marL="0" indent="0" algn="ctr">
+              <a:buNone/>
+            </a:pPr>
+            <a:r>
+              <a:rPr lang="en-US" sz="1100" dirty="0">
+                <a:solidFill>
+                  <a:srgbClr val="12262B"/>
+                </a:solidFill>
+                <a:latin typeface="Calibri" pitchFamily="34" charset="0"/>
+                <a:cs typeface="Calibri" pitchFamily="34" charset="-120"/>
+              </a:rPr>
+              <a:t>vs </a:t>
+            </a:r>
+            <a:r>
+              <a:rPr lang="en-US" sz="1100" dirty="0" err="1">
+                <a:solidFill>
+                  <a:srgbClr val="12262B"/>
+                </a:solidFill>
+                <a:latin typeface="Calibri" pitchFamily="34" charset="0"/>
+                <a:cs typeface="Calibri" pitchFamily="34" charset="-120"/>
+              </a:rPr>
+              <a:t>RNAseq</a:t>
+            </a:r>
+            <a:r>
+              <a:rPr lang="en-US" sz="1100" dirty="0">
+                <a:solidFill>
+                  <a:srgbClr val="12262B"/>
+                </a:solidFill>
+                <a:latin typeface="Calibri" pitchFamily="34" charset="0"/>
+                <a:cs typeface="Calibri" pitchFamily="34" charset="-120"/>
+              </a:rPr>
+              <a:t>?</a:t>
+            </a:r>
+            <a:endParaRPr lang="en-US" sz="1100" dirty="0"/>
+          </a:p>
+        </p:txBody>
+      </p:sp>
+      <p:sp>
+        <p:nvSpPr>
+          <p:cNvPr id="31" name="Text 18">
+            <a:extLst>
+              <a:ext uri="{FF2B5EF4-FFF2-40B4-BE49-F238E27FC236}">
+                <a16:creationId xmlns:a16="http://schemas.microsoft.com/office/drawing/2014/main" id="{91239C92-C097-E9F5-72C4-1F0F4E895689}"/>
+              </a:ext>
+            </a:extLst>
+          </p:cNvPr>
+          <p:cNvSpPr/>
+          <p:nvPr/>
+        </p:nvSpPr>
+        <p:spPr>
+          <a:xfrm>
+            <a:off x="9546336" y="2816352"/>
+            <a:ext cx="1993392" cy="365760"/>
+          </a:xfrm>
+          <a:prstGeom prst="rect">
+            <a:avLst/>
+          </a:prstGeom>
+          <a:noFill/>
+          <a:ln/>
+        </p:spPr>
+        <p:txBody>
+          <a:bodyPr wrap="square" lIns="0" tIns="0" rIns="0" bIns="0" rtlCol="0" anchor="ctr"/>
+          <a:lstStyle/>
+          <a:p>
+            <a:pPr marL="0" indent="0" algn="ctr">
+              <a:buNone/>
+            </a:pPr>
+            <a:r>
+              <a:rPr lang="en-US" sz="1100" dirty="0" err="1">
+                <a:solidFill>
+                  <a:srgbClr val="12262B"/>
+                </a:solidFill>
+                <a:latin typeface="Calibri" pitchFamily="34" charset="0"/>
+                <a:cs typeface="Calibri" pitchFamily="34" charset="-120"/>
+              </a:rPr>
+              <a:t>Normalisation</a:t>
+            </a:r>
+            <a:r>
+              <a:rPr lang="en-US" sz="1100" dirty="0">
+                <a:solidFill>
+                  <a:srgbClr val="12262B"/>
+                </a:solidFill>
+                <a:latin typeface="Calibri" pitchFamily="34" charset="0"/>
+                <a:cs typeface="Calibri" pitchFamily="34" charset="-120"/>
+              </a:rPr>
+              <a:t>?</a:t>
+            </a:r>
+            <a:endParaRPr lang="en-US" sz="1100" dirty="0"/>
           </a:p>
         </p:txBody>
       </p:sp>
@@ -26153,9 +25999,8 @@
                 <a:ea typeface="Calibri" pitchFamily="34" charset="-122"/>
                 <a:cs typeface="Calibri" pitchFamily="34" charset="-120"/>
               </a:rPr>
-              <a:t>Rows = samples (patients/tumours), columns = genes/probes — or the transpose. State your convention explicitly.</a:t>
-            </a:r>
-            <a:endParaRPr lang="en-US" sz="1600" dirty="0"/>
+              <a:t>Rows = samples (patients/tumours), </a:t>
+            </a:r>
           </a:p>
           <a:p>
             <a:pPr marL="203200" indent="-203200">
@@ -26174,7 +26019,7 @@
                 <a:ea typeface="Calibri" pitchFamily="34" charset="-122"/>
                 <a:cs typeface="Calibri" pitchFamily="34" charset="-120"/>
               </a:rPr>
-              <a:t>A typical study: ~100–500 samples × ~20,000 genes.</a:t>
+              <a:t>columns = genes/probes</a:t>
             </a:r>
             <a:endParaRPr lang="en-US" sz="1600" dirty="0"/>
           </a:p>
@@ -26195,7 +26040,28 @@
                 <a:ea typeface="Calibri" pitchFamily="34" charset="-122"/>
                 <a:cs typeface="Calibri" pitchFamily="34" charset="-120"/>
               </a:rPr>
-              <a:t>This shape is the source of nearly every difficulty in the rest of the course.</a:t>
+              <a:t>A typical study: ~100-500 samples × ~20,000 genes.</a:t>
+            </a:r>
+            <a:endParaRPr lang="en-US" sz="1600" dirty="0"/>
+          </a:p>
+          <a:p>
+            <a:pPr marL="203200" indent="-203200">
+              <a:spcAft>
+                <a:spcPts val="1400"/>
+              </a:spcAft>
+              <a:buSzPct val="100000"/>
+              <a:buChar char="•"/>
+            </a:pPr>
+            <a:r>
+              <a:rPr lang="en-US" sz="1600" dirty="0">
+                <a:solidFill>
+                  <a:srgbClr val="12262B"/>
+                </a:solidFill>
+                <a:latin typeface="Calibri" pitchFamily="34" charset="0"/>
+                <a:ea typeface="Calibri" pitchFamily="34" charset="-122"/>
+                <a:cs typeface="Calibri" pitchFamily="34" charset="-120"/>
+              </a:rPr>
+              <a:t>REMEMBER: in bioinformatics, row and columns are swapped. Rows = genes! TRANSPOSE IT!</a:t>
             </a:r>
             <a:endParaRPr lang="en-US" sz="1600" dirty="0"/>
           </a:p>
@@ -30267,7 +30133,7 @@
                 <a:ea typeface="Calibri" pitchFamily="34" charset="-122"/>
                 <a:cs typeface="Calibri" pitchFamily="34" charset="-120"/>
               </a:rPr>
-              <a:t>Features (X): expression of each gene for each sample — the wide matrix.</a:t>
+              <a:t>Features (X): expression of each gene for each sample</a:t>
             </a:r>
             <a:endParaRPr lang="en-US" sz="1600" dirty="0"/>
           </a:p>
@@ -30288,7 +30154,7 @@
                 <a:ea typeface="Calibri" pitchFamily="34" charset="-122"/>
                 <a:cs typeface="Calibri" pitchFamily="34" charset="-120"/>
               </a:rPr>
-              <a:t>Label (y): the chosen recurrence endpoint per sample — one column we are trying to predict.</a:t>
+              <a:t>Label (y): the chosen recurrence endpoint per sample</a:t>
             </a:r>
             <a:endParaRPr lang="en-US" sz="1600" dirty="0"/>
           </a:p>
@@ -30309,7 +30175,7 @@
                 <a:ea typeface="Calibri" pitchFamily="34" charset="-122"/>
                 <a:cs typeface="Calibri" pitchFamily="34" charset="-120"/>
               </a:rPr>
-              <a:t>Optional features: clinical covariates (age, tumour size, grade, nodal status).</a:t>
+              <a:t>Optional features: clinical covariates (age, tumour size, grade, nodal status). </a:t>
             </a:r>
             <a:endParaRPr lang="en-US" sz="1600" dirty="0"/>
           </a:p>
@@ -30331,6 +30197,25 @@
                 <a:cs typeface="Calibri" pitchFamily="34" charset="-120"/>
               </a:rPr>
               <a:t>Mental model: ~20,000 numbers describing each tumour, and one number we wish we knew in advance.</a:t>
+            </a:r>
+          </a:p>
+          <a:p>
+            <a:pPr marL="203200" indent="-203200">
+              <a:spcAft>
+                <a:spcPts val="1400"/>
+              </a:spcAft>
+              <a:buSzPct val="100000"/>
+              <a:buChar char="•"/>
+            </a:pPr>
+            <a:r>
+              <a:rPr lang="en-US" sz="1600" b="1" dirty="0">
+                <a:solidFill>
+                  <a:srgbClr val="0E7C86"/>
+                </a:solidFill>
+                <a:latin typeface="Calibri" pitchFamily="34" charset="0"/>
+                <a:cs typeface="Calibri" pitchFamily="34" charset="-120"/>
+              </a:rPr>
+              <a:t>QUESTION: Should age and tumor size be features, or should we test the transcriptome on its own?</a:t>
             </a:r>
             <a:endParaRPr lang="en-US" sz="1600" dirty="0"/>
           </a:p>

</xml_diff>